<commit_message>
Add Kilo Code PyCharm usage guide (06-Kilo Code在PyCharm中使用指南.md)
</commit_message>
<xml_diff>
--- a/教学实施资料/说课PPT/AI应用基础（48课时版）-课程整体说课（15分钟）.pptx
+++ b/教学实施资料/说课PPT/AI应用基础（48课时版）-课程整体说课（15分钟）.pptx
@@ -17765,8 +17765,8 @@
         </p:nvSpPr>
         <p:spPr>
           <a:xfrm>
-            <a:off x="760000" y="1600000"/>
-            <a:ext cx="5150000" cy="1150000"/>
+            <a:off x="536000" y="1720000"/>
+            <a:ext cx="3520000" cy="1500000"/>
           </a:xfrm>
           <a:prstGeom prst="rect">
             <a:avLst/>
@@ -17811,8 +17811,8 @@
         </p:nvSpPr>
         <p:spPr>
           <a:xfrm>
-            <a:off x="760000" y="1600000"/>
-            <a:ext cx="820000" cy="1150000"/>
+            <a:off x="536000" y="1720000"/>
+            <a:ext cx="3520000" cy="380000"/>
           </a:xfrm>
           <a:prstGeom prst="rect">
             <a:avLst/>
@@ -17855,8 +17855,8 @@
         </p:nvSpPr>
         <p:spPr>
           <a:xfrm>
-            <a:off x="760000" y="1890000"/>
-            <a:ext cx="820000" cy="560000"/>
+            <a:off x="696000" y="1760000"/>
+            <a:ext cx="1300000" cy="320000"/>
           </a:xfrm>
           <a:prstGeom prst="rect">
             <a:avLst/>
@@ -17869,7 +17869,7 @@
           </a:bodyPr>
           <a:lstStyle/>
           <a:p>
-            <a:pPr algn="ctr">
+            <a:pPr algn="l">
               <a:lnSpc>
                 <a:spcPct val="110000"/>
               </a:lnSpc>
@@ -17878,7 +17878,7 @@
               </a:spcAft>
             </a:pPr>
             <a:r>
-              <a:rPr sz="2200" b="1">
+              <a:rPr sz="2400" b="1">
                 <a:solidFill>
                   <a:srgbClr val="FFFFFF"/>
                 </a:solidFill>
@@ -17897,8 +17897,8 @@
         </p:nvSpPr>
         <p:spPr>
           <a:xfrm>
-            <a:off x="1740000" y="1680000"/>
-            <a:ext cx="4020000" cy="500000"/>
+            <a:off x="2036000" y="1800000"/>
+            <a:ext cx="1900000" cy="280000"/>
           </a:xfrm>
           <a:prstGeom prst="rect">
             <a:avLst/>
@@ -17911,7 +17911,7 @@
           </a:bodyPr>
           <a:lstStyle/>
           <a:p>
-            <a:pPr algn="l">
+            <a:pPr algn="r">
               <a:lnSpc>
                 <a:spcPct val="110000"/>
               </a:lnSpc>
@@ -17920,28 +17920,9 @@
               </a:spcAft>
             </a:pPr>
             <a:r>
-              <a:rPr sz="1550" b="1">
-                <a:solidFill>
-                  <a:srgbClr val="010328"/>
-                </a:solidFill>
-                <a:latin typeface="微软雅黑"/>
-              </a:rPr>
-              <a:t>课程定位</a:t>
-            </a:r>
-          </a:p>
-          <a:p>
-            <a:pPr algn="l">
-              <a:lnSpc>
-                <a:spcPct val="110000"/>
-              </a:lnSpc>
-              <a:spcAft>
-                <a:spcPts val="600"/>
-              </a:spcAft>
-            </a:pPr>
-            <a:r>
-              <a:rPr sz="1150" b="1">
-                <a:solidFill>
-                  <a:srgbClr val="0545E8"/>
+              <a:rPr sz="1200" b="1">
+                <a:solidFill>
+                  <a:srgbClr val="FFFFFF"/>
                 </a:solidFill>
                 <a:latin typeface="微软雅黑"/>
               </a:rPr>
@@ -17958,8 +17939,8 @@
         </p:nvSpPr>
         <p:spPr>
           <a:xfrm>
-            <a:off x="1740000" y="2250000"/>
-            <a:ext cx="4020000" cy="440000"/>
+            <a:off x="696000" y="2170000"/>
+            <a:ext cx="3220000" cy="420000"/>
           </a:xfrm>
           <a:prstGeom prst="rect">
             <a:avLst/>
@@ -17974,14 +17955,56 @@
           <a:p>
             <a:pPr algn="l">
               <a:lnSpc>
-                <a:spcPct val="115000"/>
-              </a:lnSpc>
-              <a:spcAft>
-                <a:spcPts val="600"/>
-              </a:spcAft>
-            </a:pPr>
-            <a:r>
-              <a:rPr sz="1100" b="0">
+                <a:spcPct val="110000"/>
+              </a:lnSpc>
+              <a:spcAft>
+                <a:spcPts val="600"/>
+              </a:spcAft>
+            </a:pPr>
+            <a:r>
+              <a:rPr sz="1700" b="1">
+                <a:solidFill>
+                  <a:srgbClr val="010328"/>
+                </a:solidFill>
+                <a:latin typeface="微软雅黑"/>
+              </a:rPr>
+              <a:t>课程定位</a:t>
+            </a:r>
+          </a:p>
+        </p:txBody>
+      </p:sp>
+      <p:sp>
+        <p:nvSpPr>
+          <p:cNvPr id="10" name="TextBox 9"/>
+          <p:cNvSpPr txBox="1"/>
+          <p:nvPr/>
+        </p:nvSpPr>
+        <p:spPr>
+          <a:xfrm>
+            <a:off x="696000" y="2600000"/>
+            <a:ext cx="3220000" cy="540000"/>
+          </a:xfrm>
+          <a:prstGeom prst="rect">
+            <a:avLst/>
+          </a:prstGeom>
+          <a:noFill/>
+        </p:spPr>
+        <p:txBody>
+          <a:bodyPr wrap="square" anchor="t">
+            <a:spAutoFit/>
+          </a:bodyPr>
+          <a:lstStyle/>
+          <a:p>
+            <a:pPr algn="l">
+              <a:lnSpc>
+                <a:spcPct val="118000"/>
+              </a:lnSpc>
+              <a:spcAft>
+                <a:spcPts val="600"/>
+              </a:spcAft>
+            </a:pPr>
+            <a:r>
+              <a:rPr sz="1150" b="0">
                 <a:solidFill>
                   <a:srgbClr val="44546A"/>
                 </a:solidFill>
@@ -17994,14 +18017,14 @@
       </p:sp>
       <p:sp>
         <p:nvSpPr>
-          <p:cNvPr id="10" name="Rectangle 9"/>
+          <p:cNvPr id="11" name="Rectangle 10"/>
           <p:cNvSpPr/>
           <p:nvPr/>
         </p:nvSpPr>
         <p:spPr>
           <a:xfrm>
-            <a:off x="6270000" y="1600000"/>
-            <a:ext cx="5150000" cy="1150000"/>
+            <a:off x="4336000" y="1720000"/>
+            <a:ext cx="3520000" cy="1500000"/>
           </a:xfrm>
           <a:prstGeom prst="rect">
             <a:avLst/>
@@ -18040,14 +18063,14 @@
       </p:sp>
       <p:sp>
         <p:nvSpPr>
-          <p:cNvPr id="11" name="Rectangle 10"/>
+          <p:cNvPr id="12" name="Rectangle 11"/>
           <p:cNvSpPr/>
           <p:nvPr/>
         </p:nvSpPr>
         <p:spPr>
           <a:xfrm>
-            <a:off x="6270000" y="1600000"/>
-            <a:ext cx="820000" cy="1150000"/>
+            <a:off x="4336000" y="1720000"/>
+            <a:ext cx="3520000" cy="380000"/>
           </a:xfrm>
           <a:prstGeom prst="rect">
             <a:avLst/>
@@ -18084,14 +18107,14 @@
       </p:sp>
       <p:sp>
         <p:nvSpPr>
-          <p:cNvPr id="12" name="TextBox 11"/>
+          <p:cNvPr id="13" name="TextBox 12"/>
           <p:cNvSpPr txBox="1"/>
           <p:nvPr/>
         </p:nvSpPr>
         <p:spPr>
           <a:xfrm>
-            <a:off x="6270000" y="1890000"/>
-            <a:ext cx="820000" cy="560000"/>
+            <a:off x="4496000" y="1760000"/>
+            <a:ext cx="1300000" cy="320000"/>
           </a:xfrm>
           <a:prstGeom prst="rect">
             <a:avLst/>
@@ -18104,7 +18127,7 @@
           </a:bodyPr>
           <a:lstStyle/>
           <a:p>
-            <a:pPr algn="ctr">
+            <a:pPr algn="l">
               <a:lnSpc>
                 <a:spcPct val="110000"/>
               </a:lnSpc>
@@ -18113,7 +18136,7 @@
               </a:spcAft>
             </a:pPr>
             <a:r>
-              <a:rPr sz="2200" b="1">
+              <a:rPr sz="2400" b="1">
                 <a:solidFill>
                   <a:srgbClr val="FFFFFF"/>
                 </a:solidFill>
@@ -18126,14 +18149,14 @@
       </p:sp>
       <p:sp>
         <p:nvSpPr>
-          <p:cNvPr id="13" name="TextBox 12"/>
+          <p:cNvPr id="14" name="TextBox 13"/>
           <p:cNvSpPr txBox="1"/>
           <p:nvPr/>
         </p:nvSpPr>
         <p:spPr>
           <a:xfrm>
-            <a:off x="7250000" y="1680000"/>
-            <a:ext cx="4020000" cy="500000"/>
+            <a:off x="5836000" y="1800000"/>
+            <a:ext cx="1900000" cy="280000"/>
           </a:xfrm>
           <a:prstGeom prst="rect">
             <a:avLst/>
@@ -18146,7 +18169,7 @@
           </a:bodyPr>
           <a:lstStyle/>
           <a:p>
-            <a:pPr algn="l">
+            <a:pPr algn="r">
               <a:lnSpc>
                 <a:spcPct val="110000"/>
               </a:lnSpc>
@@ -18155,28 +18178,9 @@
               </a:spcAft>
             </a:pPr>
             <a:r>
-              <a:rPr sz="1550" b="1">
-                <a:solidFill>
-                  <a:srgbClr val="010328"/>
-                </a:solidFill>
-                <a:latin typeface="微软雅黑"/>
-              </a:rPr>
-              <a:t>学情分析</a:t>
-            </a:r>
-          </a:p>
-          <a:p>
-            <a:pPr algn="l">
-              <a:lnSpc>
-                <a:spcPct val="110000"/>
-              </a:lnSpc>
-              <a:spcAft>
-                <a:spcPts val="600"/>
-              </a:spcAft>
-            </a:pPr>
-            <a:r>
-              <a:rPr sz="1150" b="1">
-                <a:solidFill>
-                  <a:srgbClr val="0545E8"/>
+              <a:rPr sz="1200" b="1">
+                <a:solidFill>
+                  <a:srgbClr val="FFFFFF"/>
                 </a:solidFill>
                 <a:latin typeface="微软雅黑"/>
               </a:rPr>
@@ -18187,14 +18191,14 @@
       </p:sp>
       <p:sp>
         <p:nvSpPr>
-          <p:cNvPr id="14" name="TextBox 13"/>
+          <p:cNvPr id="15" name="TextBox 14"/>
           <p:cNvSpPr txBox="1"/>
           <p:nvPr/>
         </p:nvSpPr>
         <p:spPr>
           <a:xfrm>
-            <a:off x="7250000" y="2250000"/>
-            <a:ext cx="4020000" cy="440000"/>
+            <a:off x="4496000" y="2170000"/>
+            <a:ext cx="3220000" cy="420000"/>
           </a:xfrm>
           <a:prstGeom prst="rect">
             <a:avLst/>
@@ -18209,14 +18213,56 @@
           <a:p>
             <a:pPr algn="l">
               <a:lnSpc>
-                <a:spcPct val="115000"/>
-              </a:lnSpc>
-              <a:spcAft>
-                <a:spcPts val="600"/>
-              </a:spcAft>
-            </a:pPr>
-            <a:r>
-              <a:rPr sz="1100" b="0">
+                <a:spcPct val="110000"/>
+              </a:lnSpc>
+              <a:spcAft>
+                <a:spcPts val="600"/>
+              </a:spcAft>
+            </a:pPr>
+            <a:r>
+              <a:rPr sz="1700" b="1">
+                <a:solidFill>
+                  <a:srgbClr val="010328"/>
+                </a:solidFill>
+                <a:latin typeface="微软雅黑"/>
+              </a:rPr>
+              <a:t>学情分析</a:t>
+            </a:r>
+          </a:p>
+        </p:txBody>
+      </p:sp>
+      <p:sp>
+        <p:nvSpPr>
+          <p:cNvPr id="16" name="TextBox 15"/>
+          <p:cNvSpPr txBox="1"/>
+          <p:nvPr/>
+        </p:nvSpPr>
+        <p:spPr>
+          <a:xfrm>
+            <a:off x="4496000" y="2600000"/>
+            <a:ext cx="3220000" cy="540000"/>
+          </a:xfrm>
+          <a:prstGeom prst="rect">
+            <a:avLst/>
+          </a:prstGeom>
+          <a:noFill/>
+        </p:spPr>
+        <p:txBody>
+          <a:bodyPr wrap="square" anchor="t">
+            <a:spAutoFit/>
+          </a:bodyPr>
+          <a:lstStyle/>
+          <a:p>
+            <a:pPr algn="l">
+              <a:lnSpc>
+                <a:spcPct val="118000"/>
+              </a:lnSpc>
+              <a:spcAft>
+                <a:spcPts val="600"/>
+              </a:spcAft>
+            </a:pPr>
+            <a:r>
+              <a:rPr sz="1150" b="0">
                 <a:solidFill>
                   <a:srgbClr val="44546A"/>
                 </a:solidFill>
@@ -18229,14 +18275,14 @@
       </p:sp>
       <p:sp>
         <p:nvSpPr>
-          <p:cNvPr id="15" name="Rectangle 14"/>
+          <p:cNvPr id="17" name="Rectangle 16"/>
           <p:cNvSpPr/>
           <p:nvPr/>
         </p:nvSpPr>
         <p:spPr>
           <a:xfrm>
-            <a:off x="760000" y="2930000"/>
-            <a:ext cx="5150000" cy="1150000"/>
+            <a:off x="8136000" y="1720000"/>
+            <a:ext cx="3520000" cy="1500000"/>
           </a:xfrm>
           <a:prstGeom prst="rect">
             <a:avLst/>
@@ -18275,14 +18321,14 @@
       </p:sp>
       <p:sp>
         <p:nvSpPr>
-          <p:cNvPr id="16" name="Rectangle 15"/>
+          <p:cNvPr id="18" name="Rectangle 17"/>
           <p:cNvSpPr/>
           <p:nvPr/>
         </p:nvSpPr>
         <p:spPr>
           <a:xfrm>
-            <a:off x="760000" y="2930000"/>
-            <a:ext cx="820000" cy="1150000"/>
+            <a:off x="8136000" y="1720000"/>
+            <a:ext cx="3520000" cy="380000"/>
           </a:xfrm>
           <a:prstGeom prst="rect">
             <a:avLst/>
@@ -18319,14 +18365,14 @@
       </p:sp>
       <p:sp>
         <p:nvSpPr>
-          <p:cNvPr id="17" name="TextBox 16"/>
+          <p:cNvPr id="19" name="TextBox 18"/>
           <p:cNvSpPr txBox="1"/>
           <p:nvPr/>
         </p:nvSpPr>
         <p:spPr>
           <a:xfrm>
-            <a:off x="760000" y="3220000"/>
-            <a:ext cx="820000" cy="560000"/>
+            <a:off x="8296000" y="1760000"/>
+            <a:ext cx="1300000" cy="320000"/>
           </a:xfrm>
           <a:prstGeom prst="rect">
             <a:avLst/>
@@ -18339,7 +18385,7 @@
           </a:bodyPr>
           <a:lstStyle/>
           <a:p>
-            <a:pPr algn="ctr">
+            <a:pPr algn="l">
               <a:lnSpc>
                 <a:spcPct val="110000"/>
               </a:lnSpc>
@@ -18348,7 +18394,7 @@
               </a:spcAft>
             </a:pPr>
             <a:r>
-              <a:rPr sz="2200" b="1">
+              <a:rPr sz="2400" b="1">
                 <a:solidFill>
                   <a:srgbClr val="FFFFFF"/>
                 </a:solidFill>
@@ -18361,14 +18407,14 @@
       </p:sp>
       <p:sp>
         <p:nvSpPr>
-          <p:cNvPr id="18" name="TextBox 17"/>
+          <p:cNvPr id="20" name="TextBox 19"/>
           <p:cNvSpPr txBox="1"/>
           <p:nvPr/>
         </p:nvSpPr>
         <p:spPr>
           <a:xfrm>
-            <a:off x="1740000" y="3010000"/>
-            <a:ext cx="4020000" cy="500000"/>
+            <a:off x="9636000" y="1800000"/>
+            <a:ext cx="1900000" cy="280000"/>
           </a:xfrm>
           <a:prstGeom prst="rect">
             <a:avLst/>
@@ -18381,7 +18427,7 @@
           </a:bodyPr>
           <a:lstStyle/>
           <a:p>
-            <a:pPr algn="l">
+            <a:pPr algn="r">
               <a:lnSpc>
                 <a:spcPct val="110000"/>
               </a:lnSpc>
@@ -18390,28 +18436,9 @@
               </a:spcAft>
             </a:pPr>
             <a:r>
-              <a:rPr sz="1550" b="1">
-                <a:solidFill>
-                  <a:srgbClr val="010328"/>
-                </a:solidFill>
-                <a:latin typeface="微软雅黑"/>
-              </a:rPr>
-              <a:t>课程目标</a:t>
-            </a:r>
-          </a:p>
-          <a:p>
-            <a:pPr algn="l">
-              <a:lnSpc>
-                <a:spcPct val="110000"/>
-              </a:lnSpc>
-              <a:spcAft>
-                <a:spcPts val="600"/>
-              </a:spcAft>
-            </a:pPr>
-            <a:r>
-              <a:rPr sz="1150" b="1">
-                <a:solidFill>
-                  <a:srgbClr val="0545E8"/>
+              <a:rPr sz="1200" b="1">
+                <a:solidFill>
+                  <a:srgbClr val="FFFFFF"/>
                 </a:solidFill>
                 <a:latin typeface="微软雅黑"/>
               </a:rPr>
@@ -18422,14 +18449,14 @@
       </p:sp>
       <p:sp>
         <p:nvSpPr>
-          <p:cNvPr id="19" name="TextBox 18"/>
+          <p:cNvPr id="21" name="TextBox 20"/>
           <p:cNvSpPr txBox="1"/>
           <p:nvPr/>
         </p:nvSpPr>
         <p:spPr>
           <a:xfrm>
-            <a:off x="1740000" y="3580000"/>
-            <a:ext cx="4020000" cy="440000"/>
+            <a:off x="8296000" y="2170000"/>
+            <a:ext cx="3220000" cy="420000"/>
           </a:xfrm>
           <a:prstGeom prst="rect">
             <a:avLst/>
@@ -18444,14 +18471,56 @@
           <a:p>
             <a:pPr algn="l">
               <a:lnSpc>
-                <a:spcPct val="115000"/>
-              </a:lnSpc>
-              <a:spcAft>
-                <a:spcPts val="600"/>
-              </a:spcAft>
-            </a:pPr>
-            <a:r>
-              <a:rPr sz="1100" b="0">
+                <a:spcPct val="110000"/>
+              </a:lnSpc>
+              <a:spcAft>
+                <a:spcPts val="600"/>
+              </a:spcAft>
+            </a:pPr>
+            <a:r>
+              <a:rPr sz="1700" b="1">
+                <a:solidFill>
+                  <a:srgbClr val="010328"/>
+                </a:solidFill>
+                <a:latin typeface="微软雅黑"/>
+              </a:rPr>
+              <a:t>课程目标</a:t>
+            </a:r>
+          </a:p>
+        </p:txBody>
+      </p:sp>
+      <p:sp>
+        <p:nvSpPr>
+          <p:cNvPr id="22" name="TextBox 21"/>
+          <p:cNvSpPr txBox="1"/>
+          <p:nvPr/>
+        </p:nvSpPr>
+        <p:spPr>
+          <a:xfrm>
+            <a:off x="8296000" y="2600000"/>
+            <a:ext cx="3220000" cy="540000"/>
+          </a:xfrm>
+          <a:prstGeom prst="rect">
+            <a:avLst/>
+          </a:prstGeom>
+          <a:noFill/>
+        </p:spPr>
+        <p:txBody>
+          <a:bodyPr wrap="square" anchor="t">
+            <a:spAutoFit/>
+          </a:bodyPr>
+          <a:lstStyle/>
+          <a:p>
+            <a:pPr algn="l">
+              <a:lnSpc>
+                <a:spcPct val="118000"/>
+              </a:lnSpc>
+              <a:spcAft>
+                <a:spcPts val="600"/>
+              </a:spcAft>
+            </a:pPr>
+            <a:r>
+              <a:rPr sz="1150" b="0">
                 <a:solidFill>
                   <a:srgbClr val="44546A"/>
                 </a:solidFill>
@@ -18464,14 +18533,14 @@
       </p:sp>
       <p:sp>
         <p:nvSpPr>
-          <p:cNvPr id="20" name="Rectangle 19"/>
+          <p:cNvPr id="23" name="Rectangle 22"/>
           <p:cNvSpPr/>
           <p:nvPr/>
         </p:nvSpPr>
         <p:spPr>
           <a:xfrm>
-            <a:off x="6270000" y="2930000"/>
-            <a:ext cx="5150000" cy="1150000"/>
+            <a:off x="536000" y="3420000"/>
+            <a:ext cx="3520000" cy="1500000"/>
           </a:xfrm>
           <a:prstGeom prst="rect">
             <a:avLst/>
@@ -18510,14 +18579,14 @@
       </p:sp>
       <p:sp>
         <p:nvSpPr>
-          <p:cNvPr id="21" name="Rectangle 20"/>
+          <p:cNvPr id="24" name="Rectangle 23"/>
           <p:cNvSpPr/>
           <p:nvPr/>
         </p:nvSpPr>
         <p:spPr>
           <a:xfrm>
-            <a:off x="6270000" y="2930000"/>
-            <a:ext cx="820000" cy="1150000"/>
+            <a:off x="536000" y="3420000"/>
+            <a:ext cx="3520000" cy="380000"/>
           </a:xfrm>
           <a:prstGeom prst="rect">
             <a:avLst/>
@@ -18554,14 +18623,14 @@
       </p:sp>
       <p:sp>
         <p:nvSpPr>
-          <p:cNvPr id="22" name="TextBox 21"/>
+          <p:cNvPr id="25" name="TextBox 24"/>
           <p:cNvSpPr txBox="1"/>
           <p:nvPr/>
         </p:nvSpPr>
         <p:spPr>
           <a:xfrm>
-            <a:off x="6270000" y="3220000"/>
-            <a:ext cx="820000" cy="560000"/>
+            <a:off x="696000" y="3460000"/>
+            <a:ext cx="1300000" cy="320000"/>
           </a:xfrm>
           <a:prstGeom prst="rect">
             <a:avLst/>
@@ -18574,7 +18643,7 @@
           </a:bodyPr>
           <a:lstStyle/>
           <a:p>
-            <a:pPr algn="ctr">
+            <a:pPr algn="l">
               <a:lnSpc>
                 <a:spcPct val="110000"/>
               </a:lnSpc>
@@ -18583,7 +18652,7 @@
               </a:spcAft>
             </a:pPr>
             <a:r>
-              <a:rPr sz="2200" b="1">
+              <a:rPr sz="2400" b="1">
                 <a:solidFill>
                   <a:srgbClr val="FFFFFF"/>
                 </a:solidFill>
@@ -18596,14 +18665,14 @@
       </p:sp>
       <p:sp>
         <p:nvSpPr>
-          <p:cNvPr id="23" name="TextBox 22"/>
+          <p:cNvPr id="26" name="TextBox 25"/>
           <p:cNvSpPr txBox="1"/>
           <p:nvPr/>
         </p:nvSpPr>
         <p:spPr>
           <a:xfrm>
-            <a:off x="7250000" y="3010000"/>
-            <a:ext cx="4020000" cy="500000"/>
+            <a:off x="2036000" y="3500000"/>
+            <a:ext cx="1900000" cy="280000"/>
           </a:xfrm>
           <a:prstGeom prst="rect">
             <a:avLst/>
@@ -18616,7 +18685,7 @@
           </a:bodyPr>
           <a:lstStyle/>
           <a:p>
-            <a:pPr algn="l">
+            <a:pPr algn="r">
               <a:lnSpc>
                 <a:spcPct val="110000"/>
               </a:lnSpc>
@@ -18625,28 +18694,9 @@
               </a:spcAft>
             </a:pPr>
             <a:r>
-              <a:rPr sz="1550" b="1">
-                <a:solidFill>
-                  <a:srgbClr val="010328"/>
-                </a:solidFill>
-                <a:latin typeface="微软雅黑"/>
-              </a:rPr>
-              <a:t>内容与结构</a:t>
-            </a:r>
-          </a:p>
-          <a:p>
-            <a:pPr algn="l">
-              <a:lnSpc>
-                <a:spcPct val="110000"/>
-              </a:lnSpc>
-              <a:spcAft>
-                <a:spcPts val="600"/>
-              </a:spcAft>
-            </a:pPr>
-            <a:r>
-              <a:rPr sz="1150" b="1">
-                <a:solidFill>
-                  <a:srgbClr val="0545E8"/>
+              <a:rPr sz="1200" b="1">
+                <a:solidFill>
+                  <a:srgbClr val="FFFFFF"/>
                 </a:solidFill>
                 <a:latin typeface="微软雅黑"/>
               </a:rPr>
@@ -18657,14 +18707,14 @@
       </p:sp>
       <p:sp>
         <p:nvSpPr>
-          <p:cNvPr id="24" name="TextBox 23"/>
+          <p:cNvPr id="27" name="TextBox 26"/>
           <p:cNvSpPr txBox="1"/>
           <p:nvPr/>
         </p:nvSpPr>
         <p:spPr>
           <a:xfrm>
-            <a:off x="7250000" y="3580000"/>
-            <a:ext cx="4020000" cy="440000"/>
+            <a:off x="696000" y="3870000"/>
+            <a:ext cx="3220000" cy="420000"/>
           </a:xfrm>
           <a:prstGeom prst="rect">
             <a:avLst/>
@@ -18679,14 +18729,56 @@
           <a:p>
             <a:pPr algn="l">
               <a:lnSpc>
-                <a:spcPct val="115000"/>
-              </a:lnSpc>
-              <a:spcAft>
-                <a:spcPts val="600"/>
-              </a:spcAft>
-            </a:pPr>
-            <a:r>
-              <a:rPr sz="1100" b="0">
+                <a:spcPct val="110000"/>
+              </a:lnSpc>
+              <a:spcAft>
+                <a:spcPts val="600"/>
+              </a:spcAft>
+            </a:pPr>
+            <a:r>
+              <a:rPr sz="1700" b="1">
+                <a:solidFill>
+                  <a:srgbClr val="010328"/>
+                </a:solidFill>
+                <a:latin typeface="微软雅黑"/>
+              </a:rPr>
+              <a:t>内容与结构</a:t>
+            </a:r>
+          </a:p>
+        </p:txBody>
+      </p:sp>
+      <p:sp>
+        <p:nvSpPr>
+          <p:cNvPr id="28" name="TextBox 27"/>
+          <p:cNvSpPr txBox="1"/>
+          <p:nvPr/>
+        </p:nvSpPr>
+        <p:spPr>
+          <a:xfrm>
+            <a:off x="696000" y="4300000"/>
+            <a:ext cx="3220000" cy="540000"/>
+          </a:xfrm>
+          <a:prstGeom prst="rect">
+            <a:avLst/>
+          </a:prstGeom>
+          <a:noFill/>
+        </p:spPr>
+        <p:txBody>
+          <a:bodyPr wrap="square" anchor="t">
+            <a:spAutoFit/>
+          </a:bodyPr>
+          <a:lstStyle/>
+          <a:p>
+            <a:pPr algn="l">
+              <a:lnSpc>
+                <a:spcPct val="118000"/>
+              </a:lnSpc>
+              <a:spcAft>
+                <a:spcPts val="600"/>
+              </a:spcAft>
+            </a:pPr>
+            <a:r>
+              <a:rPr sz="1150" b="0">
                 <a:solidFill>
                   <a:srgbClr val="44546A"/>
                 </a:solidFill>
@@ -18699,14 +18791,14 @@
       </p:sp>
       <p:sp>
         <p:nvSpPr>
-          <p:cNvPr id="25" name="Rectangle 24"/>
+          <p:cNvPr id="29" name="Rectangle 28"/>
           <p:cNvSpPr/>
           <p:nvPr/>
         </p:nvSpPr>
         <p:spPr>
           <a:xfrm>
-            <a:off x="760000" y="4260000"/>
-            <a:ext cx="5150000" cy="1150000"/>
+            <a:off x="4336000" y="3420000"/>
+            <a:ext cx="3520000" cy="1500000"/>
           </a:xfrm>
           <a:prstGeom prst="rect">
             <a:avLst/>
@@ -18745,14 +18837,14 @@
       </p:sp>
       <p:sp>
         <p:nvSpPr>
-          <p:cNvPr id="26" name="Rectangle 25"/>
+          <p:cNvPr id="30" name="Rectangle 29"/>
           <p:cNvSpPr/>
           <p:nvPr/>
         </p:nvSpPr>
         <p:spPr>
           <a:xfrm>
-            <a:off x="760000" y="4260000"/>
-            <a:ext cx="820000" cy="1150000"/>
+            <a:off x="4336000" y="3420000"/>
+            <a:ext cx="3520000" cy="380000"/>
           </a:xfrm>
           <a:prstGeom prst="rect">
             <a:avLst/>
@@ -18789,14 +18881,14 @@
       </p:sp>
       <p:sp>
         <p:nvSpPr>
-          <p:cNvPr id="27" name="TextBox 26"/>
+          <p:cNvPr id="31" name="TextBox 30"/>
           <p:cNvSpPr txBox="1"/>
           <p:nvPr/>
         </p:nvSpPr>
         <p:spPr>
           <a:xfrm>
-            <a:off x="760000" y="4550000"/>
-            <a:ext cx="820000" cy="560000"/>
+            <a:off x="4496000" y="3460000"/>
+            <a:ext cx="1300000" cy="320000"/>
           </a:xfrm>
           <a:prstGeom prst="rect">
             <a:avLst/>
@@ -18809,7 +18901,7 @@
           </a:bodyPr>
           <a:lstStyle/>
           <a:p>
-            <a:pPr algn="ctr">
+            <a:pPr algn="l">
               <a:lnSpc>
                 <a:spcPct val="110000"/>
               </a:lnSpc>
@@ -18818,7 +18910,7 @@
               </a:spcAft>
             </a:pPr>
             <a:r>
-              <a:rPr sz="2200" b="1">
+              <a:rPr sz="2400" b="1">
                 <a:solidFill>
                   <a:srgbClr val="FFFFFF"/>
                 </a:solidFill>
@@ -18831,14 +18923,14 @@
       </p:sp>
       <p:sp>
         <p:nvSpPr>
-          <p:cNvPr id="28" name="TextBox 27"/>
+          <p:cNvPr id="32" name="TextBox 31"/>
           <p:cNvSpPr txBox="1"/>
           <p:nvPr/>
         </p:nvSpPr>
         <p:spPr>
           <a:xfrm>
-            <a:off x="1740000" y="4340000"/>
-            <a:ext cx="4020000" cy="500000"/>
+            <a:off x="5836000" y="3500000"/>
+            <a:ext cx="1900000" cy="280000"/>
           </a:xfrm>
           <a:prstGeom prst="rect">
             <a:avLst/>
@@ -18851,7 +18943,7 @@
           </a:bodyPr>
           <a:lstStyle/>
           <a:p>
-            <a:pPr algn="l">
+            <a:pPr algn="r">
               <a:lnSpc>
                 <a:spcPct val="110000"/>
               </a:lnSpc>
@@ -18860,28 +18952,9 @@
               </a:spcAft>
             </a:pPr>
             <a:r>
-              <a:rPr sz="1550" b="1">
-                <a:solidFill>
-                  <a:srgbClr val="010328"/>
-                </a:solidFill>
-                <a:latin typeface="微软雅黑"/>
-              </a:rPr>
-              <a:t>教学设计</a:t>
-            </a:r>
-          </a:p>
-          <a:p>
-            <a:pPr algn="l">
-              <a:lnSpc>
-                <a:spcPct val="110000"/>
-              </a:lnSpc>
-              <a:spcAft>
-                <a:spcPts val="600"/>
-              </a:spcAft>
-            </a:pPr>
-            <a:r>
-              <a:rPr sz="1150" b="1">
-                <a:solidFill>
-                  <a:srgbClr val="0545E8"/>
+              <a:rPr sz="1200" b="1">
+                <a:solidFill>
+                  <a:srgbClr val="FFFFFF"/>
                 </a:solidFill>
                 <a:latin typeface="微软雅黑"/>
               </a:rPr>
@@ -18892,14 +18965,14 @@
       </p:sp>
       <p:sp>
         <p:nvSpPr>
-          <p:cNvPr id="29" name="TextBox 28"/>
+          <p:cNvPr id="33" name="TextBox 32"/>
           <p:cNvSpPr txBox="1"/>
           <p:nvPr/>
         </p:nvSpPr>
         <p:spPr>
           <a:xfrm>
-            <a:off x="1740000" y="4910000"/>
-            <a:ext cx="4020000" cy="440000"/>
+            <a:off x="4496000" y="3870000"/>
+            <a:ext cx="3220000" cy="420000"/>
           </a:xfrm>
           <a:prstGeom prst="rect">
             <a:avLst/>
@@ -18914,14 +18987,56 @@
           <a:p>
             <a:pPr algn="l">
               <a:lnSpc>
-                <a:spcPct val="115000"/>
-              </a:lnSpc>
-              <a:spcAft>
-                <a:spcPts val="600"/>
-              </a:spcAft>
-            </a:pPr>
-            <a:r>
-              <a:rPr sz="1100" b="0">
+                <a:spcPct val="110000"/>
+              </a:lnSpc>
+              <a:spcAft>
+                <a:spcPts val="600"/>
+              </a:spcAft>
+            </a:pPr>
+            <a:r>
+              <a:rPr sz="1700" b="1">
+                <a:solidFill>
+                  <a:srgbClr val="010328"/>
+                </a:solidFill>
+                <a:latin typeface="微软雅黑"/>
+              </a:rPr>
+              <a:t>教学设计</a:t>
+            </a:r>
+          </a:p>
+        </p:txBody>
+      </p:sp>
+      <p:sp>
+        <p:nvSpPr>
+          <p:cNvPr id="34" name="TextBox 33"/>
+          <p:cNvSpPr txBox="1"/>
+          <p:nvPr/>
+        </p:nvSpPr>
+        <p:spPr>
+          <a:xfrm>
+            <a:off x="4496000" y="4300000"/>
+            <a:ext cx="3220000" cy="540000"/>
+          </a:xfrm>
+          <a:prstGeom prst="rect">
+            <a:avLst/>
+          </a:prstGeom>
+          <a:noFill/>
+        </p:spPr>
+        <p:txBody>
+          <a:bodyPr wrap="square" anchor="t">
+            <a:spAutoFit/>
+          </a:bodyPr>
+          <a:lstStyle/>
+          <a:p>
+            <a:pPr algn="l">
+              <a:lnSpc>
+                <a:spcPct val="118000"/>
+              </a:lnSpc>
+              <a:spcAft>
+                <a:spcPts val="600"/>
+              </a:spcAft>
+            </a:pPr>
+            <a:r>
+              <a:rPr sz="1150" b="0">
                 <a:solidFill>
                   <a:srgbClr val="44546A"/>
                 </a:solidFill>
@@ -18934,14 +19049,14 @@
       </p:sp>
       <p:sp>
         <p:nvSpPr>
-          <p:cNvPr id="30" name="Rectangle 29"/>
+          <p:cNvPr id="35" name="Rectangle 34"/>
           <p:cNvSpPr/>
           <p:nvPr/>
         </p:nvSpPr>
         <p:spPr>
           <a:xfrm>
-            <a:off x="6270000" y="4260000"/>
-            <a:ext cx="5150000" cy="1150000"/>
+            <a:off x="8136000" y="3420000"/>
+            <a:ext cx="3520000" cy="1500000"/>
           </a:xfrm>
           <a:prstGeom prst="rect">
             <a:avLst/>
@@ -18980,14 +19095,14 @@
       </p:sp>
       <p:sp>
         <p:nvSpPr>
-          <p:cNvPr id="31" name="Rectangle 30"/>
+          <p:cNvPr id="36" name="Rectangle 35"/>
           <p:cNvSpPr/>
           <p:nvPr/>
         </p:nvSpPr>
         <p:spPr>
           <a:xfrm>
-            <a:off x="6270000" y="4260000"/>
-            <a:ext cx="820000" cy="1150000"/>
+            <a:off x="8136000" y="3420000"/>
+            <a:ext cx="3520000" cy="380000"/>
           </a:xfrm>
           <a:prstGeom prst="rect">
             <a:avLst/>
@@ -19024,14 +19139,14 @@
       </p:sp>
       <p:sp>
         <p:nvSpPr>
-          <p:cNvPr id="32" name="TextBox 31"/>
+          <p:cNvPr id="37" name="TextBox 36"/>
           <p:cNvSpPr txBox="1"/>
           <p:nvPr/>
         </p:nvSpPr>
         <p:spPr>
           <a:xfrm>
-            <a:off x="6270000" y="4550000"/>
-            <a:ext cx="820000" cy="560000"/>
+            <a:off x="8296000" y="3460000"/>
+            <a:ext cx="1300000" cy="320000"/>
           </a:xfrm>
           <a:prstGeom prst="rect">
             <a:avLst/>
@@ -19044,7 +19159,7 @@
           </a:bodyPr>
           <a:lstStyle/>
           <a:p>
-            <a:pPr algn="ctr">
+            <a:pPr algn="l">
               <a:lnSpc>
                 <a:spcPct val="110000"/>
               </a:lnSpc>
@@ -19053,7 +19168,7 @@
               </a:spcAft>
             </a:pPr>
             <a:r>
-              <a:rPr sz="2200" b="1">
+              <a:rPr sz="2400" b="1">
                 <a:solidFill>
                   <a:srgbClr val="FFFFFF"/>
                 </a:solidFill>
@@ -19066,14 +19181,14 @@
       </p:sp>
       <p:sp>
         <p:nvSpPr>
-          <p:cNvPr id="33" name="TextBox 32"/>
+          <p:cNvPr id="38" name="TextBox 37"/>
           <p:cNvSpPr txBox="1"/>
           <p:nvPr/>
         </p:nvSpPr>
         <p:spPr>
           <a:xfrm>
-            <a:off x="7250000" y="4340000"/>
-            <a:ext cx="4020000" cy="500000"/>
+            <a:off x="9636000" y="3500000"/>
+            <a:ext cx="1900000" cy="280000"/>
           </a:xfrm>
           <a:prstGeom prst="rect">
             <a:avLst/>
@@ -19086,7 +19201,7 @@
           </a:bodyPr>
           <a:lstStyle/>
           <a:p>
-            <a:pPr algn="l">
+            <a:pPr algn="r">
               <a:lnSpc>
                 <a:spcPct val="110000"/>
               </a:lnSpc>
@@ -19095,28 +19210,9 @@
               </a:spcAft>
             </a:pPr>
             <a:r>
-              <a:rPr sz="1550" b="1">
-                <a:solidFill>
-                  <a:srgbClr val="010328"/>
-                </a:solidFill>
-                <a:latin typeface="微软雅黑"/>
-              </a:rPr>
-              <a:t>教学资源</a:t>
-            </a:r>
-          </a:p>
-          <a:p>
-            <a:pPr algn="l">
-              <a:lnSpc>
-                <a:spcPct val="110000"/>
-              </a:lnSpc>
-              <a:spcAft>
-                <a:spcPts val="600"/>
-              </a:spcAft>
-            </a:pPr>
-            <a:r>
-              <a:rPr sz="1150" b="1">
-                <a:solidFill>
-                  <a:srgbClr val="0545E8"/>
+              <a:rPr sz="1200" b="1">
+                <a:solidFill>
+                  <a:srgbClr val="FFFFFF"/>
                 </a:solidFill>
                 <a:latin typeface="微软雅黑"/>
               </a:rPr>
@@ -19127,14 +19223,14 @@
       </p:sp>
       <p:sp>
         <p:nvSpPr>
-          <p:cNvPr id="34" name="TextBox 33"/>
+          <p:cNvPr id="39" name="TextBox 38"/>
           <p:cNvSpPr txBox="1"/>
           <p:nvPr/>
         </p:nvSpPr>
         <p:spPr>
           <a:xfrm>
-            <a:off x="7250000" y="4910000"/>
-            <a:ext cx="4020000" cy="440000"/>
+            <a:off x="8296000" y="3870000"/>
+            <a:ext cx="3220000" cy="420000"/>
           </a:xfrm>
           <a:prstGeom prst="rect">
             <a:avLst/>
@@ -19149,14 +19245,56 @@
           <a:p>
             <a:pPr algn="l">
               <a:lnSpc>
-                <a:spcPct val="115000"/>
-              </a:lnSpc>
-              <a:spcAft>
-                <a:spcPts val="600"/>
-              </a:spcAft>
-            </a:pPr>
-            <a:r>
-              <a:rPr sz="1100" b="0">
+                <a:spcPct val="110000"/>
+              </a:lnSpc>
+              <a:spcAft>
+                <a:spcPts val="600"/>
+              </a:spcAft>
+            </a:pPr>
+            <a:r>
+              <a:rPr sz="1700" b="1">
+                <a:solidFill>
+                  <a:srgbClr val="010328"/>
+                </a:solidFill>
+                <a:latin typeface="微软雅黑"/>
+              </a:rPr>
+              <a:t>教学资源</a:t>
+            </a:r>
+          </a:p>
+        </p:txBody>
+      </p:sp>
+      <p:sp>
+        <p:nvSpPr>
+          <p:cNvPr id="40" name="TextBox 39"/>
+          <p:cNvSpPr txBox="1"/>
+          <p:nvPr/>
+        </p:nvSpPr>
+        <p:spPr>
+          <a:xfrm>
+            <a:off x="8296000" y="4300000"/>
+            <a:ext cx="3220000" cy="540000"/>
+          </a:xfrm>
+          <a:prstGeom prst="rect">
+            <a:avLst/>
+          </a:prstGeom>
+          <a:noFill/>
+        </p:spPr>
+        <p:txBody>
+          <a:bodyPr wrap="square" anchor="t">
+            <a:spAutoFit/>
+          </a:bodyPr>
+          <a:lstStyle/>
+          <a:p>
+            <a:pPr algn="l">
+              <a:lnSpc>
+                <a:spcPct val="118000"/>
+              </a:lnSpc>
+              <a:spcAft>
+                <a:spcPts val="600"/>
+              </a:spcAft>
+            </a:pPr>
+            <a:r>
+              <a:rPr sz="1150" b="0">
                 <a:solidFill>
                   <a:srgbClr val="44546A"/>
                 </a:solidFill>
@@ -19169,14 +19307,14 @@
       </p:sp>
       <p:sp>
         <p:nvSpPr>
-          <p:cNvPr id="35" name="Rectangle 34"/>
+          <p:cNvPr id="41" name="Rectangle 40"/>
           <p:cNvSpPr/>
           <p:nvPr/>
         </p:nvSpPr>
         <p:spPr>
           <a:xfrm>
-            <a:off x="760000" y="5590000"/>
-            <a:ext cx="5150000" cy="1150000"/>
+            <a:off x="536000" y="5120000"/>
+            <a:ext cx="3520000" cy="1500000"/>
           </a:xfrm>
           <a:prstGeom prst="rect">
             <a:avLst/>
@@ -19215,14 +19353,14 @@
       </p:sp>
       <p:sp>
         <p:nvSpPr>
-          <p:cNvPr id="36" name="Rectangle 35"/>
+          <p:cNvPr id="42" name="Rectangle 41"/>
           <p:cNvSpPr/>
           <p:nvPr/>
         </p:nvSpPr>
         <p:spPr>
           <a:xfrm>
-            <a:off x="760000" y="5590000"/>
-            <a:ext cx="820000" cy="1150000"/>
+            <a:off x="536000" y="5120000"/>
+            <a:ext cx="3520000" cy="380000"/>
           </a:xfrm>
           <a:prstGeom prst="rect">
             <a:avLst/>
@@ -19259,14 +19397,14 @@
       </p:sp>
       <p:sp>
         <p:nvSpPr>
-          <p:cNvPr id="37" name="TextBox 36"/>
+          <p:cNvPr id="43" name="TextBox 42"/>
           <p:cNvSpPr txBox="1"/>
           <p:nvPr/>
         </p:nvSpPr>
         <p:spPr>
           <a:xfrm>
-            <a:off x="760000" y="5880000"/>
-            <a:ext cx="820000" cy="560000"/>
+            <a:off x="696000" y="5160000"/>
+            <a:ext cx="1300000" cy="320000"/>
           </a:xfrm>
           <a:prstGeom prst="rect">
             <a:avLst/>
@@ -19279,7 +19417,7 @@
           </a:bodyPr>
           <a:lstStyle/>
           <a:p>
-            <a:pPr algn="ctr">
+            <a:pPr algn="l">
               <a:lnSpc>
                 <a:spcPct val="110000"/>
               </a:lnSpc>
@@ -19288,7 +19426,7 @@
               </a:spcAft>
             </a:pPr>
             <a:r>
-              <a:rPr sz="2200" b="1">
+              <a:rPr sz="2400" b="1">
                 <a:solidFill>
                   <a:srgbClr val="FFFFFF"/>
                 </a:solidFill>
@@ -19301,14 +19439,14 @@
       </p:sp>
       <p:sp>
         <p:nvSpPr>
-          <p:cNvPr id="38" name="TextBox 37"/>
+          <p:cNvPr id="44" name="TextBox 43"/>
           <p:cNvSpPr txBox="1"/>
           <p:nvPr/>
         </p:nvSpPr>
         <p:spPr>
           <a:xfrm>
-            <a:off x="1740000" y="5670000"/>
-            <a:ext cx="4020000" cy="500000"/>
+            <a:off x="2036000" y="5200000"/>
+            <a:ext cx="1900000" cy="280000"/>
           </a:xfrm>
           <a:prstGeom prst="rect">
             <a:avLst/>
@@ -19321,7 +19459,7 @@
           </a:bodyPr>
           <a:lstStyle/>
           <a:p>
-            <a:pPr algn="l">
+            <a:pPr algn="r">
               <a:lnSpc>
                 <a:spcPct val="110000"/>
               </a:lnSpc>
@@ -19330,28 +19468,9 @@
               </a:spcAft>
             </a:pPr>
             <a:r>
-              <a:rPr sz="1550" b="1">
-                <a:solidFill>
-                  <a:srgbClr val="010328"/>
-                </a:solidFill>
-                <a:latin typeface="微软雅黑"/>
-              </a:rPr>
-              <a:t>考核评价</a:t>
-            </a:r>
-          </a:p>
-          <a:p>
-            <a:pPr algn="l">
-              <a:lnSpc>
-                <a:spcPct val="110000"/>
-              </a:lnSpc>
-              <a:spcAft>
-                <a:spcPts val="600"/>
-              </a:spcAft>
-            </a:pPr>
-            <a:r>
-              <a:rPr sz="1150" b="1">
-                <a:solidFill>
-                  <a:srgbClr val="0545E8"/>
+              <a:rPr sz="1200" b="1">
+                <a:solidFill>
+                  <a:srgbClr val="FFFFFF"/>
                 </a:solidFill>
                 <a:latin typeface="微软雅黑"/>
               </a:rPr>
@@ -19362,14 +19481,14 @@
       </p:sp>
       <p:sp>
         <p:nvSpPr>
-          <p:cNvPr id="39" name="TextBox 38"/>
+          <p:cNvPr id="45" name="TextBox 44"/>
           <p:cNvSpPr txBox="1"/>
           <p:nvPr/>
         </p:nvSpPr>
         <p:spPr>
           <a:xfrm>
-            <a:off x="1740000" y="6240000"/>
-            <a:ext cx="4020000" cy="440000"/>
+            <a:off x="696000" y="5570000"/>
+            <a:ext cx="3220000" cy="420000"/>
           </a:xfrm>
           <a:prstGeom prst="rect">
             <a:avLst/>
@@ -19384,14 +19503,56 @@
           <a:p>
             <a:pPr algn="l">
               <a:lnSpc>
-                <a:spcPct val="115000"/>
-              </a:lnSpc>
-              <a:spcAft>
-                <a:spcPts val="600"/>
-              </a:spcAft>
-            </a:pPr>
-            <a:r>
-              <a:rPr sz="1100" b="0">
+                <a:spcPct val="110000"/>
+              </a:lnSpc>
+              <a:spcAft>
+                <a:spcPts val="600"/>
+              </a:spcAft>
+            </a:pPr>
+            <a:r>
+              <a:rPr sz="1700" b="1">
+                <a:solidFill>
+                  <a:srgbClr val="010328"/>
+                </a:solidFill>
+                <a:latin typeface="微软雅黑"/>
+              </a:rPr>
+              <a:t>考核评价</a:t>
+            </a:r>
+          </a:p>
+        </p:txBody>
+      </p:sp>
+      <p:sp>
+        <p:nvSpPr>
+          <p:cNvPr id="46" name="TextBox 45"/>
+          <p:cNvSpPr txBox="1"/>
+          <p:nvPr/>
+        </p:nvSpPr>
+        <p:spPr>
+          <a:xfrm>
+            <a:off x="696000" y="6000000"/>
+            <a:ext cx="3220000" cy="540000"/>
+          </a:xfrm>
+          <a:prstGeom prst="rect">
+            <a:avLst/>
+          </a:prstGeom>
+          <a:noFill/>
+        </p:spPr>
+        <p:txBody>
+          <a:bodyPr wrap="square" anchor="t">
+            <a:spAutoFit/>
+          </a:bodyPr>
+          <a:lstStyle/>
+          <a:p>
+            <a:pPr algn="l">
+              <a:lnSpc>
+                <a:spcPct val="118000"/>
+              </a:lnSpc>
+              <a:spcAft>
+                <a:spcPts val="600"/>
+              </a:spcAft>
+            </a:pPr>
+            <a:r>
+              <a:rPr sz="1150" b="0">
                 <a:solidFill>
                   <a:srgbClr val="44546A"/>
                 </a:solidFill>
@@ -19404,14 +19565,14 @@
       </p:sp>
       <p:sp>
         <p:nvSpPr>
-          <p:cNvPr id="40" name="Rectangle 39"/>
+          <p:cNvPr id="47" name="Rectangle 46"/>
           <p:cNvSpPr/>
           <p:nvPr/>
         </p:nvSpPr>
         <p:spPr>
           <a:xfrm>
-            <a:off x="6270000" y="5590000"/>
-            <a:ext cx="5150000" cy="1150000"/>
+            <a:off x="4336000" y="5120000"/>
+            <a:ext cx="3520000" cy="1500000"/>
           </a:xfrm>
           <a:prstGeom prst="rect">
             <a:avLst/>
@@ -19450,14 +19611,14 @@
       </p:sp>
       <p:sp>
         <p:nvSpPr>
-          <p:cNvPr id="41" name="Rectangle 40"/>
+          <p:cNvPr id="48" name="Rectangle 47"/>
           <p:cNvSpPr/>
           <p:nvPr/>
         </p:nvSpPr>
         <p:spPr>
           <a:xfrm>
-            <a:off x="6270000" y="5590000"/>
-            <a:ext cx="820000" cy="1150000"/>
+            <a:off x="4336000" y="5120000"/>
+            <a:ext cx="3520000" cy="380000"/>
           </a:xfrm>
           <a:prstGeom prst="rect">
             <a:avLst/>
@@ -19494,14 +19655,14 @@
       </p:sp>
       <p:sp>
         <p:nvSpPr>
-          <p:cNvPr id="42" name="TextBox 41"/>
+          <p:cNvPr id="49" name="TextBox 48"/>
           <p:cNvSpPr txBox="1"/>
           <p:nvPr/>
         </p:nvSpPr>
         <p:spPr>
           <a:xfrm>
-            <a:off x="6270000" y="5880000"/>
-            <a:ext cx="820000" cy="560000"/>
+            <a:off x="4496000" y="5160000"/>
+            <a:ext cx="1300000" cy="320000"/>
           </a:xfrm>
           <a:prstGeom prst="rect">
             <a:avLst/>
@@ -19514,7 +19675,7 @@
           </a:bodyPr>
           <a:lstStyle/>
           <a:p>
-            <a:pPr algn="ctr">
+            <a:pPr algn="l">
               <a:lnSpc>
                 <a:spcPct val="110000"/>
               </a:lnSpc>
@@ -19523,7 +19684,7 @@
               </a:spcAft>
             </a:pPr>
             <a:r>
-              <a:rPr sz="2200" b="1">
+              <a:rPr sz="2400" b="1">
                 <a:solidFill>
                   <a:srgbClr val="FFFFFF"/>
                 </a:solidFill>
@@ -19536,14 +19697,14 @@
       </p:sp>
       <p:sp>
         <p:nvSpPr>
-          <p:cNvPr id="43" name="TextBox 42"/>
+          <p:cNvPr id="50" name="TextBox 49"/>
           <p:cNvSpPr txBox="1"/>
           <p:nvPr/>
         </p:nvSpPr>
         <p:spPr>
           <a:xfrm>
-            <a:off x="7250000" y="5670000"/>
-            <a:ext cx="4020000" cy="500000"/>
+            <a:off x="5836000" y="5200000"/>
+            <a:ext cx="1900000" cy="280000"/>
           </a:xfrm>
           <a:prstGeom prst="rect">
             <a:avLst/>
@@ -19556,7 +19717,7 @@
           </a:bodyPr>
           <a:lstStyle/>
           <a:p>
-            <a:pPr algn="l">
+            <a:pPr algn="r">
               <a:lnSpc>
                 <a:spcPct val="110000"/>
               </a:lnSpc>
@@ -19565,28 +19726,9 @@
               </a:spcAft>
             </a:pPr>
             <a:r>
-              <a:rPr sz="1550" b="1">
-                <a:solidFill>
-                  <a:srgbClr val="010328"/>
-                </a:solidFill>
-                <a:latin typeface="微软雅黑"/>
-              </a:rPr>
-              <a:t>特色与成效</a:t>
-            </a:r>
-          </a:p>
-          <a:p>
-            <a:pPr algn="l">
-              <a:lnSpc>
-                <a:spcPct val="110000"/>
-              </a:lnSpc>
-              <a:spcAft>
-                <a:spcPts val="600"/>
-              </a:spcAft>
-            </a:pPr>
-            <a:r>
-              <a:rPr sz="1150" b="1">
-                <a:solidFill>
-                  <a:srgbClr val="0545E8"/>
+              <a:rPr sz="1200" b="1">
+                <a:solidFill>
+                  <a:srgbClr val="FFFFFF"/>
                 </a:solidFill>
                 <a:latin typeface="微软雅黑"/>
               </a:rPr>
@@ -19597,14 +19739,14 @@
       </p:sp>
       <p:sp>
         <p:nvSpPr>
-          <p:cNvPr id="44" name="TextBox 43"/>
+          <p:cNvPr id="51" name="TextBox 50"/>
           <p:cNvSpPr txBox="1"/>
           <p:nvPr/>
         </p:nvSpPr>
         <p:spPr>
           <a:xfrm>
-            <a:off x="7250000" y="6240000"/>
-            <a:ext cx="4020000" cy="440000"/>
+            <a:off x="4496000" y="5570000"/>
+            <a:ext cx="3220000" cy="420000"/>
           </a:xfrm>
           <a:prstGeom prst="rect">
             <a:avLst/>
@@ -19619,14 +19761,56 @@
           <a:p>
             <a:pPr algn="l">
               <a:lnSpc>
-                <a:spcPct val="115000"/>
-              </a:lnSpc>
-              <a:spcAft>
-                <a:spcPts val="600"/>
-              </a:spcAft>
-            </a:pPr>
-            <a:r>
-              <a:rPr sz="1100" b="0">
+                <a:spcPct val="110000"/>
+              </a:lnSpc>
+              <a:spcAft>
+                <a:spcPts val="600"/>
+              </a:spcAft>
+            </a:pPr>
+            <a:r>
+              <a:rPr sz="1700" b="1">
+                <a:solidFill>
+                  <a:srgbClr val="010328"/>
+                </a:solidFill>
+                <a:latin typeface="微软雅黑"/>
+              </a:rPr>
+              <a:t>特色与成效</a:t>
+            </a:r>
+          </a:p>
+        </p:txBody>
+      </p:sp>
+      <p:sp>
+        <p:nvSpPr>
+          <p:cNvPr id="52" name="TextBox 51"/>
+          <p:cNvSpPr txBox="1"/>
+          <p:nvPr/>
+        </p:nvSpPr>
+        <p:spPr>
+          <a:xfrm>
+            <a:off x="4496000" y="6000000"/>
+            <a:ext cx="3220000" cy="540000"/>
+          </a:xfrm>
+          <a:prstGeom prst="rect">
+            <a:avLst/>
+          </a:prstGeom>
+          <a:noFill/>
+        </p:spPr>
+        <p:txBody>
+          <a:bodyPr wrap="square" anchor="t">
+            <a:spAutoFit/>
+          </a:bodyPr>
+          <a:lstStyle/>
+          <a:p>
+            <a:pPr algn="l">
+              <a:lnSpc>
+                <a:spcPct val="118000"/>
+              </a:lnSpc>
+              <a:spcAft>
+                <a:spcPts val="600"/>
+              </a:spcAft>
+            </a:pPr>
+            <a:r>
+              <a:rPr sz="1150" b="0">
                 <a:solidFill>
                   <a:srgbClr val="44546A"/>
                 </a:solidFill>
@@ -19639,7 +19823,154 @@
       </p:sp>
       <p:sp>
         <p:nvSpPr>
-          <p:cNvPr id="45" name="Rectangle 44"/>
+          <p:cNvPr id="53" name="Rectangle 52"/>
+          <p:cNvSpPr/>
+          <p:nvPr/>
+        </p:nvSpPr>
+        <p:spPr>
+          <a:xfrm>
+            <a:off x="8136000" y="5120000"/>
+            <a:ext cx="3520000" cy="1500000"/>
+          </a:xfrm>
+          <a:prstGeom prst="rect">
+            <a:avLst/>
+          </a:prstGeom>
+          <a:solidFill>
+            <a:srgbClr val="010328"/>
+          </a:solidFill>
+          <a:ln>
+            <a:noFill/>
+          </a:ln>
+          <a:effectLst/>
+        </p:spPr>
+        <p:style>
+          <a:lnRef idx="1">
+            <a:schemeClr val="accent1"/>
+          </a:lnRef>
+          <a:fillRef idx="3">
+            <a:schemeClr val="accent1"/>
+          </a:fillRef>
+          <a:effectRef idx="2">
+            <a:schemeClr val="accent1"/>
+          </a:effectRef>
+          <a:fontRef idx="minor">
+            <a:schemeClr val="lt1"/>
+          </a:fontRef>
+        </p:style>
+        <p:txBody>
+          <a:bodyPr rtlCol="0" anchor="ctr"/>
+          <a:lstStyle/>
+          <a:p>
+            <a:pPr algn="ctr"/>
+          </a:p>
+        </p:txBody>
+      </p:sp>
+      <p:sp>
+        <p:nvSpPr>
+          <p:cNvPr id="54" name="TextBox 53"/>
+          <p:cNvSpPr txBox="1"/>
+          <p:nvPr/>
+        </p:nvSpPr>
+        <p:spPr>
+          <a:xfrm>
+            <a:off x="8276000" y="5300000"/>
+            <a:ext cx="3240000" cy="420000"/>
+          </a:xfrm>
+          <a:prstGeom prst="rect">
+            <a:avLst/>
+          </a:prstGeom>
+          <a:noFill/>
+        </p:spPr>
+        <p:txBody>
+          <a:bodyPr wrap="square" anchor="t">
+            <a:spAutoFit/>
+          </a:bodyPr>
+          <a:lstStyle/>
+          <a:p>
+            <a:pPr algn="ctr">
+              <a:lnSpc>
+                <a:spcPct val="110000"/>
+              </a:lnSpc>
+              <a:spcAft>
+                <a:spcPts val="600"/>
+              </a:spcAft>
+            </a:pPr>
+            <a:r>
+              <a:rPr sz="1900" b="1">
+                <a:solidFill>
+                  <a:srgbClr val="FFFFFF"/>
+                </a:solidFill>
+                <a:latin typeface="微软雅黑"/>
+              </a:rPr>
+              <a:t>15分钟 · 八环节</a:t>
+            </a:r>
+          </a:p>
+        </p:txBody>
+      </p:sp>
+      <p:sp>
+        <p:nvSpPr>
+          <p:cNvPr id="55" name="TextBox 54"/>
+          <p:cNvSpPr txBox="1"/>
+          <p:nvPr/>
+        </p:nvSpPr>
+        <p:spPr>
+          <a:xfrm>
+            <a:off x="8276000" y="5760000"/>
+            <a:ext cx="3240000" cy="700000"/>
+          </a:xfrm>
+          <a:prstGeom prst="rect">
+            <a:avLst/>
+          </a:prstGeom>
+          <a:noFill/>
+        </p:spPr>
+        <p:txBody>
+          <a:bodyPr wrap="square" anchor="t">
+            <a:spAutoFit/>
+          </a:bodyPr>
+          <a:lstStyle/>
+          <a:p>
+            <a:pPr algn="ctr">
+              <a:lnSpc>
+                <a:spcPct val="125000"/>
+              </a:lnSpc>
+              <a:spcAft>
+                <a:spcPts val="600"/>
+              </a:spcAft>
+            </a:pPr>
+            <a:r>
+              <a:rPr sz="1150" b="0">
+                <a:solidFill>
+                  <a:srgbClr val="0475B6"/>
+                </a:solidFill>
+                <a:latin typeface="微软雅黑"/>
+              </a:rPr>
+              <a:t>定位→学情→目标→内容→</a:t>
+            </a:r>
+          </a:p>
+          <a:p>
+            <a:pPr algn="ctr">
+              <a:lnSpc>
+                <a:spcPct val="125000"/>
+              </a:lnSpc>
+              <a:spcAft>
+                <a:spcPts val="600"/>
+              </a:spcAft>
+            </a:pPr>
+            <a:r>
+              <a:rPr sz="1150" b="0">
+                <a:solidFill>
+                  <a:srgbClr val="0475B6"/>
+                </a:solidFill>
+                <a:latin typeface="微软雅黑"/>
+              </a:rPr>
+              <a:t>设计→资源→评价→特色成效</a:t>
+            </a:r>
+          </a:p>
+        </p:txBody>
+      </p:sp>
+      <p:sp>
+        <p:nvSpPr>
+          <p:cNvPr id="56" name="Rectangle 55"/>
           <p:cNvSpPr/>
           <p:nvPr/>
         </p:nvSpPr>
@@ -19683,7 +20014,7 @@
       </p:sp>
       <p:sp>
         <p:nvSpPr>
-          <p:cNvPr id="46" name="TextBox 45"/>
+          <p:cNvPr id="57" name="TextBox 56"/>
           <p:cNvSpPr txBox="1"/>
           <p:nvPr/>
         </p:nvSpPr>
@@ -19725,7 +20056,7 @@
       </p:sp>
       <p:sp>
         <p:nvSpPr>
-          <p:cNvPr id="47" name="TextBox 46"/>
+          <p:cNvPr id="58" name="TextBox 57"/>
           <p:cNvSpPr txBox="1"/>
           <p:nvPr/>
         </p:nvSpPr>
@@ -27645,14 +27976,60 @@
         </p:nvSpPr>
         <p:spPr>
           <a:xfrm>
-            <a:off x="760000" y="1750000"/>
-            <a:ext cx="10900000" cy="880000"/>
+            <a:off x="626000" y="1880000"/>
+            <a:ext cx="2100000" cy="4270000"/>
           </a:xfrm>
           <a:prstGeom prst="rect">
             <a:avLst/>
           </a:prstGeom>
           <a:solidFill>
             <a:srgbClr val="F3F6FD"/>
+          </a:solidFill>
+          <a:ln>
+            <a:solidFill>
+              <a:srgbClr val="0545E8"/>
+            </a:solidFill>
+          </a:ln>
+          <a:effectLst/>
+        </p:spPr>
+        <p:style>
+          <a:lnRef idx="1">
+            <a:schemeClr val="accent1"/>
+          </a:lnRef>
+          <a:fillRef idx="3">
+            <a:schemeClr val="accent1"/>
+          </a:fillRef>
+          <a:effectRef idx="2">
+            <a:schemeClr val="accent1"/>
+          </a:effectRef>
+          <a:fontRef idx="minor">
+            <a:schemeClr val="lt1"/>
+          </a:fontRef>
+        </p:style>
+        <p:txBody>
+          <a:bodyPr rtlCol="0" anchor="ctr"/>
+          <a:lstStyle/>
+          <a:p>
+            <a:pPr algn="ctr"/>
+          </a:p>
+        </p:txBody>
+      </p:sp>
+      <p:sp>
+        <p:nvSpPr>
+          <p:cNvPr id="6" name="Rectangle 5"/>
+          <p:cNvSpPr/>
+          <p:nvPr/>
+        </p:nvSpPr>
+        <p:spPr>
+          <a:xfrm>
+            <a:off x="626000" y="1880000"/>
+            <a:ext cx="2100000" cy="560000"/>
+          </a:xfrm>
+          <a:prstGeom prst="rect">
+            <a:avLst/>
+          </a:prstGeom>
+          <a:solidFill>
+            <a:srgbClr val="010328"/>
           </a:solidFill>
           <a:ln>
             <a:noFill/>
@@ -27683,14 +28060,144 @@
       </p:sp>
       <p:sp>
         <p:nvSpPr>
-          <p:cNvPr id="6" name="Rectangle 5"/>
+          <p:cNvPr id="7" name="TextBox 6"/>
+          <p:cNvSpPr txBox="1"/>
+          <p:nvPr/>
+        </p:nvSpPr>
+        <p:spPr>
+          <a:xfrm>
+            <a:off x="626000" y="2030000"/>
+            <a:ext cx="2100000" cy="320000"/>
+          </a:xfrm>
+          <a:prstGeom prst="rect">
+            <a:avLst/>
+          </a:prstGeom>
+          <a:noFill/>
+        </p:spPr>
+        <p:txBody>
+          <a:bodyPr wrap="square" anchor="t">
+            <a:spAutoFit/>
+          </a:bodyPr>
+          <a:lstStyle/>
+          <a:p>
+            <a:pPr algn="ctr">
+              <a:lnSpc>
+                <a:spcPct val="110000"/>
+              </a:lnSpc>
+              <a:spcAft>
+                <a:spcPts val="600"/>
+              </a:spcAft>
+            </a:pPr>
+            <a:r>
+              <a:rPr sz="1450" b="1">
+                <a:solidFill>
+                  <a:srgbClr val="FFFFFF"/>
+                </a:solidFill>
+                <a:latin typeface="微软雅黑"/>
+              </a:rPr>
+              <a:t>课程性质</a:t>
+            </a:r>
+          </a:p>
+        </p:txBody>
+      </p:sp>
+      <p:sp>
+        <p:nvSpPr>
+          <p:cNvPr id="8" name="TextBox 7"/>
+          <p:cNvSpPr txBox="1"/>
+          <p:nvPr/>
+        </p:nvSpPr>
+        <p:spPr>
+          <a:xfrm>
+            <a:off x="756000" y="2540000"/>
+            <a:ext cx="1840000" cy="3490000"/>
+          </a:xfrm>
+          <a:prstGeom prst="rect">
+            <a:avLst/>
+          </a:prstGeom>
+          <a:noFill/>
+        </p:spPr>
+        <p:txBody>
+          <a:bodyPr wrap="square" anchor="t">
+            <a:spAutoFit/>
+          </a:bodyPr>
+          <a:lstStyle/>
+          <a:p>
+            <a:pPr algn="l">
+              <a:lnSpc>
+                <a:spcPct val="130000"/>
+              </a:lnSpc>
+              <a:spcAft>
+                <a:spcPts val="600"/>
+              </a:spcAft>
+            </a:pPr>
+            <a:r>
+              <a:rPr sz="1150" b="0">
+                <a:solidFill>
+                  <a:srgbClr val="010328"/>
+                </a:solidFill>
+                <a:latin typeface="微软雅黑"/>
+              </a:rPr>
+              <a:t>专业核心课程扩展版：48课时覆盖'数据处理→机器学习→深度学习→视觉→大模型→智能体'全谱系</a:t>
+            </a:r>
+          </a:p>
+        </p:txBody>
+      </p:sp>
+      <p:sp>
+        <p:nvSpPr>
+          <p:cNvPr id="9" name="Rectangle 8"/>
           <p:cNvSpPr/>
           <p:nvPr/>
         </p:nvSpPr>
         <p:spPr>
           <a:xfrm>
-            <a:off x="760000" y="1750000"/>
-            <a:ext cx="150000" cy="880000"/>
+            <a:off x="2836000" y="1880000"/>
+            <a:ext cx="2100000" cy="4270000"/>
+          </a:xfrm>
+          <a:prstGeom prst="rect">
+            <a:avLst/>
+          </a:prstGeom>
+          <a:solidFill>
+            <a:srgbClr val="F3F6FD"/>
+          </a:solidFill>
+          <a:ln>
+            <a:solidFill>
+              <a:srgbClr val="0545E8"/>
+            </a:solidFill>
+          </a:ln>
+          <a:effectLst/>
+        </p:spPr>
+        <p:style>
+          <a:lnRef idx="1">
+            <a:schemeClr val="accent1"/>
+          </a:lnRef>
+          <a:fillRef idx="3">
+            <a:schemeClr val="accent1"/>
+          </a:fillRef>
+          <a:effectRef idx="2">
+            <a:schemeClr val="accent1"/>
+          </a:effectRef>
+          <a:fontRef idx="minor">
+            <a:schemeClr val="lt1"/>
+          </a:fontRef>
+        </p:style>
+        <p:txBody>
+          <a:bodyPr rtlCol="0" anchor="ctr"/>
+          <a:lstStyle/>
+          <a:p>
+            <a:pPr algn="ctr"/>
+          </a:p>
+        </p:txBody>
+      </p:sp>
+      <p:sp>
+        <p:nvSpPr>
+          <p:cNvPr id="10" name="Rectangle 9"/>
+          <p:cNvSpPr/>
+          <p:nvPr/>
+        </p:nvSpPr>
+        <p:spPr>
+          <a:xfrm>
+            <a:off x="2836000" y="1880000"/>
+            <a:ext cx="2100000" cy="560000"/>
           </a:xfrm>
           <a:prstGeom prst="rect">
             <a:avLst/>
@@ -27727,14 +28234,14 @@
       </p:sp>
       <p:sp>
         <p:nvSpPr>
-          <p:cNvPr id="7" name="TextBox 6"/>
+          <p:cNvPr id="11" name="TextBox 10"/>
           <p:cNvSpPr txBox="1"/>
           <p:nvPr/>
         </p:nvSpPr>
         <p:spPr>
           <a:xfrm>
-            <a:off x="1030000" y="1990000"/>
-            <a:ext cx="2300000" cy="400000"/>
+            <a:off x="2836000" y="2030000"/>
+            <a:ext cx="2100000" cy="320000"/>
           </a:xfrm>
           <a:prstGeom prst="rect">
             <a:avLst/>
@@ -27747,7 +28254,7 @@
           </a:bodyPr>
           <a:lstStyle/>
           <a:p>
-            <a:pPr algn="l">
+            <a:pPr algn="ctr">
               <a:lnSpc>
                 <a:spcPct val="110000"/>
               </a:lnSpc>
@@ -27756,75 +28263,121 @@
               </a:spcAft>
             </a:pPr>
             <a:r>
-              <a:rPr sz="1400" b="1">
-                <a:solidFill>
-                  <a:srgbClr val="0545E8"/>
-                </a:solidFill>
-                <a:latin typeface="微软雅黑"/>
-              </a:rPr>
-              <a:t>课程性质</a:t>
-            </a:r>
-          </a:p>
-        </p:txBody>
-      </p:sp>
-      <p:sp>
-        <p:nvSpPr>
-          <p:cNvPr id="8" name="TextBox 7"/>
+              <a:rPr sz="1450" b="1">
+                <a:solidFill>
+                  <a:srgbClr val="FFFFFF"/>
+                </a:solidFill>
+                <a:latin typeface="微软雅黑"/>
+              </a:rPr>
+              <a:t>面向岗位</a:t>
+            </a:r>
+          </a:p>
+        </p:txBody>
+      </p:sp>
+      <p:sp>
+        <p:nvSpPr>
+          <p:cNvPr id="12" name="TextBox 11"/>
           <p:cNvSpPr txBox="1"/>
           <p:nvPr/>
         </p:nvSpPr>
         <p:spPr>
           <a:xfrm>
-            <a:off x="3500000" y="1840000"/>
-            <a:ext cx="9100000" cy="720000"/>
-          </a:xfrm>
-          <a:prstGeom prst="rect">
-            <a:avLst/>
-          </a:prstGeom>
-          <a:noFill/>
-        </p:spPr>
-        <p:txBody>
-          <a:bodyPr wrap="square" anchor="ctr">
+            <a:off x="2966000" y="2540000"/>
+            <a:ext cx="1840000" cy="3490000"/>
+          </a:xfrm>
+          <a:prstGeom prst="rect">
+            <a:avLst/>
+          </a:prstGeom>
+          <a:noFill/>
+        </p:spPr>
+        <p:txBody>
+          <a:bodyPr wrap="square" anchor="t">
             <a:spAutoFit/>
           </a:bodyPr>
           <a:lstStyle/>
           <a:p>
             <a:pPr algn="l">
               <a:lnSpc>
-                <a:spcPct val="115000"/>
-              </a:lnSpc>
-              <a:spcAft>
-                <a:spcPts val="600"/>
-              </a:spcAft>
-            </a:pPr>
-            <a:r>
-              <a:rPr sz="1200" b="0">
+                <a:spcPct val="130000"/>
+              </a:lnSpc>
+              <a:spcAft>
+                <a:spcPts val="600"/>
+              </a:spcAft>
+            </a:pPr>
+            <a:r>
+              <a:rPr sz="1150" b="0">
                 <a:solidFill>
                   <a:srgbClr val="010328"/>
                 </a:solidFill>
                 <a:latin typeface="微软雅黑"/>
               </a:rPr>
-              <a:t>专业核心课程扩展版：48课时覆盖'数据处理→机器学习→深度学习→视觉→大模型→智能体'全谱系</a:t>
-            </a:r>
-          </a:p>
-        </p:txBody>
-      </p:sp>
-      <p:sp>
-        <p:nvSpPr>
-          <p:cNvPr id="9" name="Rectangle 8"/>
+              <a:t>AI应用工程师、工业视觉开发、工业互联网数据分析</a:t>
+            </a:r>
+          </a:p>
+        </p:txBody>
+      </p:sp>
+      <p:sp>
+        <p:nvSpPr>
+          <p:cNvPr id="13" name="Rectangle 12"/>
           <p:cNvSpPr/>
           <p:nvPr/>
         </p:nvSpPr>
         <p:spPr>
           <a:xfrm>
-            <a:off x="760000" y="2740000"/>
-            <a:ext cx="10900000" cy="880000"/>
+            <a:off x="5046000" y="1880000"/>
+            <a:ext cx="2100000" cy="4270000"/>
           </a:xfrm>
           <a:prstGeom prst="rect">
             <a:avLst/>
           </a:prstGeom>
           <a:solidFill>
             <a:srgbClr val="F3F6FD"/>
+          </a:solidFill>
+          <a:ln>
+            <a:solidFill>
+              <a:srgbClr val="0545E8"/>
+            </a:solidFill>
+          </a:ln>
+          <a:effectLst/>
+        </p:spPr>
+        <p:style>
+          <a:lnRef idx="1">
+            <a:schemeClr val="accent1"/>
+          </a:lnRef>
+          <a:fillRef idx="3">
+            <a:schemeClr val="accent1"/>
+          </a:fillRef>
+          <a:effectRef idx="2">
+            <a:schemeClr val="accent1"/>
+          </a:effectRef>
+          <a:fontRef idx="minor">
+            <a:schemeClr val="lt1"/>
+          </a:fontRef>
+        </p:style>
+        <p:txBody>
+          <a:bodyPr rtlCol="0" anchor="ctr"/>
+          <a:lstStyle/>
+          <a:p>
+            <a:pPr algn="ctr"/>
+          </a:p>
+        </p:txBody>
+      </p:sp>
+      <p:sp>
+        <p:nvSpPr>
+          <p:cNvPr id="14" name="Rectangle 13"/>
+          <p:cNvSpPr/>
+          <p:nvPr/>
+        </p:nvSpPr>
+        <p:spPr>
+          <a:xfrm>
+            <a:off x="5046000" y="1880000"/>
+            <a:ext cx="2100000" cy="560000"/>
+          </a:xfrm>
+          <a:prstGeom prst="rect">
+            <a:avLst/>
+          </a:prstGeom>
+          <a:solidFill>
+            <a:srgbClr val="0475B6"/>
           </a:solidFill>
           <a:ln>
             <a:noFill/>
@@ -27855,20 +28408,150 @@
       </p:sp>
       <p:sp>
         <p:nvSpPr>
-          <p:cNvPr id="10" name="Rectangle 9"/>
+          <p:cNvPr id="15" name="TextBox 14"/>
+          <p:cNvSpPr txBox="1"/>
+          <p:nvPr/>
+        </p:nvSpPr>
+        <p:spPr>
+          <a:xfrm>
+            <a:off x="5046000" y="2030000"/>
+            <a:ext cx="2100000" cy="320000"/>
+          </a:xfrm>
+          <a:prstGeom prst="rect">
+            <a:avLst/>
+          </a:prstGeom>
+          <a:noFill/>
+        </p:spPr>
+        <p:txBody>
+          <a:bodyPr wrap="square" anchor="t">
+            <a:spAutoFit/>
+          </a:bodyPr>
+          <a:lstStyle/>
+          <a:p>
+            <a:pPr algn="ctr">
+              <a:lnSpc>
+                <a:spcPct val="110000"/>
+              </a:lnSpc>
+              <a:spcAft>
+                <a:spcPts val="600"/>
+              </a:spcAft>
+            </a:pPr>
+            <a:r>
+              <a:rPr sz="1450" b="1">
+                <a:solidFill>
+                  <a:srgbClr val="FFFFFF"/>
+                </a:solidFill>
+                <a:latin typeface="微软雅黑"/>
+              </a:rPr>
+              <a:t>学时学分</a:t>
+            </a:r>
+          </a:p>
+        </p:txBody>
+      </p:sp>
+      <p:sp>
+        <p:nvSpPr>
+          <p:cNvPr id="16" name="TextBox 15"/>
+          <p:cNvSpPr txBox="1"/>
+          <p:nvPr/>
+        </p:nvSpPr>
+        <p:spPr>
+          <a:xfrm>
+            <a:off x="5176000" y="2540000"/>
+            <a:ext cx="1840000" cy="3490000"/>
+          </a:xfrm>
+          <a:prstGeom prst="rect">
+            <a:avLst/>
+          </a:prstGeom>
+          <a:noFill/>
+        </p:spPr>
+        <p:txBody>
+          <a:bodyPr wrap="square" anchor="t">
+            <a:spAutoFit/>
+          </a:bodyPr>
+          <a:lstStyle/>
+          <a:p>
+            <a:pPr algn="l">
+              <a:lnSpc>
+                <a:spcPct val="130000"/>
+              </a:lnSpc>
+              <a:spcAft>
+                <a:spcPts val="600"/>
+              </a:spcAft>
+            </a:pPr>
+            <a:r>
+              <a:rPr sz="1150" b="0">
+                <a:solidFill>
+                  <a:srgbClr val="010328"/>
+                </a:solidFill>
+                <a:latin typeface="微软雅黑"/>
+              </a:rPr>
+              <a:t>48学时（理论24+实训24）· 3学分 · 第5-16周（12周×4课时，Python开课4周后即第5周开课）</a:t>
+            </a:r>
+          </a:p>
+        </p:txBody>
+      </p:sp>
+      <p:sp>
+        <p:nvSpPr>
+          <p:cNvPr id="17" name="Rectangle 16"/>
           <p:cNvSpPr/>
           <p:nvPr/>
         </p:nvSpPr>
         <p:spPr>
           <a:xfrm>
-            <a:off x="760000" y="2740000"/>
-            <a:ext cx="150000" cy="880000"/>
+            <a:off x="7256000" y="1880000"/>
+            <a:ext cx="2100000" cy="4270000"/>
           </a:xfrm>
           <a:prstGeom prst="rect">
             <a:avLst/>
           </a:prstGeom>
           <a:solidFill>
-            <a:srgbClr val="0545E8"/>
+            <a:srgbClr val="F3F6FD"/>
+          </a:solidFill>
+          <a:ln>
+            <a:solidFill>
+              <a:srgbClr val="0545E8"/>
+            </a:solidFill>
+          </a:ln>
+          <a:effectLst/>
+        </p:spPr>
+        <p:style>
+          <a:lnRef idx="1">
+            <a:schemeClr val="accent1"/>
+          </a:lnRef>
+          <a:fillRef idx="3">
+            <a:schemeClr val="accent1"/>
+          </a:fillRef>
+          <a:effectRef idx="2">
+            <a:schemeClr val="accent1"/>
+          </a:effectRef>
+          <a:fontRef idx="minor">
+            <a:schemeClr val="lt1"/>
+          </a:fontRef>
+        </p:style>
+        <p:txBody>
+          <a:bodyPr rtlCol="0" anchor="ctr"/>
+          <a:lstStyle/>
+          <a:p>
+            <a:pPr algn="ctr"/>
+          </a:p>
+        </p:txBody>
+      </p:sp>
+      <p:sp>
+        <p:nvSpPr>
+          <p:cNvPr id="18" name="Rectangle 17"/>
+          <p:cNvSpPr/>
+          <p:nvPr/>
+        </p:nvSpPr>
+        <p:spPr>
+          <a:xfrm>
+            <a:off x="7256000" y="1880000"/>
+            <a:ext cx="2100000" cy="560000"/>
+          </a:xfrm>
+          <a:prstGeom prst="rect">
+            <a:avLst/>
+          </a:prstGeom>
+          <a:solidFill>
+            <a:srgbClr val="F5670F"/>
           </a:solidFill>
           <a:ln>
             <a:noFill/>
@@ -27899,14 +28582,14 @@
       </p:sp>
       <p:sp>
         <p:nvSpPr>
-          <p:cNvPr id="11" name="TextBox 10"/>
+          <p:cNvPr id="19" name="TextBox 18"/>
           <p:cNvSpPr txBox="1"/>
           <p:nvPr/>
         </p:nvSpPr>
         <p:spPr>
           <a:xfrm>
-            <a:off x="1030000" y="2980000"/>
-            <a:ext cx="2300000" cy="400000"/>
+            <a:off x="7256000" y="2030000"/>
+            <a:ext cx="2100000" cy="320000"/>
           </a:xfrm>
           <a:prstGeom prst="rect">
             <a:avLst/>
@@ -27919,7 +28602,7 @@
           </a:bodyPr>
           <a:lstStyle/>
           <a:p>
-            <a:pPr algn="l">
+            <a:pPr algn="ctr">
               <a:lnSpc>
                 <a:spcPct val="110000"/>
               </a:lnSpc>
@@ -27928,75 +28611,121 @@
               </a:spcAft>
             </a:pPr>
             <a:r>
-              <a:rPr sz="1400" b="1">
-                <a:solidFill>
-                  <a:srgbClr val="0545E8"/>
-                </a:solidFill>
-                <a:latin typeface="微软雅黑"/>
-              </a:rPr>
-              <a:t>面向岗位</a:t>
-            </a:r>
-          </a:p>
-        </p:txBody>
-      </p:sp>
-      <p:sp>
-        <p:nvSpPr>
-          <p:cNvPr id="12" name="TextBox 11"/>
+              <a:rPr sz="1450" b="1">
+                <a:solidFill>
+                  <a:srgbClr val="FFFFFF"/>
+                </a:solidFill>
+                <a:latin typeface="微软雅黑"/>
+              </a:rPr>
+              <a:t>对接证书</a:t>
+            </a:r>
+          </a:p>
+        </p:txBody>
+      </p:sp>
+      <p:sp>
+        <p:nvSpPr>
+          <p:cNvPr id="20" name="TextBox 19"/>
           <p:cNvSpPr txBox="1"/>
           <p:nvPr/>
         </p:nvSpPr>
         <p:spPr>
           <a:xfrm>
-            <a:off x="3500000" y="2830000"/>
-            <a:ext cx="9100000" cy="720000"/>
-          </a:xfrm>
-          <a:prstGeom prst="rect">
-            <a:avLst/>
-          </a:prstGeom>
-          <a:noFill/>
-        </p:spPr>
-        <p:txBody>
-          <a:bodyPr wrap="square" anchor="ctr">
+            <a:off x="7386000" y="2540000"/>
+            <a:ext cx="1840000" cy="3490000"/>
+          </a:xfrm>
+          <a:prstGeom prst="rect">
+            <a:avLst/>
+          </a:prstGeom>
+          <a:noFill/>
+        </p:spPr>
+        <p:txBody>
+          <a:bodyPr wrap="square" anchor="t">
             <a:spAutoFit/>
           </a:bodyPr>
           <a:lstStyle/>
           <a:p>
             <a:pPr algn="l">
               <a:lnSpc>
-                <a:spcPct val="115000"/>
-              </a:lnSpc>
-              <a:spcAft>
-                <a:spcPts val="600"/>
-              </a:spcAft>
-            </a:pPr>
-            <a:r>
-              <a:rPr sz="1200" b="0">
+                <a:spcPct val="130000"/>
+              </a:lnSpc>
+              <a:spcAft>
+                <a:spcPts val="600"/>
+              </a:spcAft>
+            </a:pPr>
+            <a:r>
+              <a:rPr sz="1150" b="0">
                 <a:solidFill>
                   <a:srgbClr val="010328"/>
                 </a:solidFill>
                 <a:latin typeface="微软雅黑"/>
               </a:rPr>
-              <a:t>AI应用工程师、工业视觉开发、工业互联网数据分析</a:t>
-            </a:r>
-          </a:p>
-        </p:txBody>
-      </p:sp>
-      <p:sp>
-        <p:nvSpPr>
-          <p:cNvPr id="13" name="Rectangle 12"/>
+              <a:t>1+X AI应用实践（初级=M1-M3/中级=M4/高级=M5）</a:t>
+            </a:r>
+          </a:p>
+        </p:txBody>
+      </p:sp>
+      <p:sp>
+        <p:nvSpPr>
+          <p:cNvPr id="21" name="Rectangle 20"/>
           <p:cNvSpPr/>
           <p:nvPr/>
         </p:nvSpPr>
         <p:spPr>
           <a:xfrm>
-            <a:off x="760000" y="3730000"/>
-            <a:ext cx="10900000" cy="880000"/>
+            <a:off x="9466000" y="1880000"/>
+            <a:ext cx="2100000" cy="4270000"/>
           </a:xfrm>
           <a:prstGeom prst="rect">
             <a:avLst/>
           </a:prstGeom>
           <a:solidFill>
             <a:srgbClr val="F3F6FD"/>
+          </a:solidFill>
+          <a:ln>
+            <a:solidFill>
+              <a:srgbClr val="0545E8"/>
+            </a:solidFill>
+          </a:ln>
+          <a:effectLst/>
+        </p:spPr>
+        <p:style>
+          <a:lnRef idx="1">
+            <a:schemeClr val="accent1"/>
+          </a:lnRef>
+          <a:fillRef idx="3">
+            <a:schemeClr val="accent1"/>
+          </a:fillRef>
+          <a:effectRef idx="2">
+            <a:schemeClr val="accent1"/>
+          </a:effectRef>
+          <a:fontRef idx="minor">
+            <a:schemeClr val="lt1"/>
+          </a:fontRef>
+        </p:style>
+        <p:txBody>
+          <a:bodyPr rtlCol="0" anchor="ctr"/>
+          <a:lstStyle/>
+          <a:p>
+            <a:pPr algn="ctr"/>
+          </a:p>
+        </p:txBody>
+      </p:sp>
+      <p:sp>
+        <p:nvSpPr>
+          <p:cNvPr id="22" name="Rectangle 21"/>
+          <p:cNvSpPr/>
+          <p:nvPr/>
+        </p:nvSpPr>
+        <p:spPr>
+          <a:xfrm>
+            <a:off x="9466000" y="1880000"/>
+            <a:ext cx="2100000" cy="560000"/>
+          </a:xfrm>
+          <a:prstGeom prst="rect">
+            <a:avLst/>
+          </a:prstGeom>
+          <a:solidFill>
+            <a:srgbClr val="44546A"/>
           </a:solidFill>
           <a:ln>
             <a:noFill/>
@@ -28027,58 +28756,14 @@
       </p:sp>
       <p:sp>
         <p:nvSpPr>
-          <p:cNvPr id="14" name="Rectangle 13"/>
-          <p:cNvSpPr/>
-          <p:nvPr/>
-        </p:nvSpPr>
-        <p:spPr>
-          <a:xfrm>
-            <a:off x="760000" y="3730000"/>
-            <a:ext cx="150000" cy="880000"/>
-          </a:xfrm>
-          <a:prstGeom prst="rect">
-            <a:avLst/>
-          </a:prstGeom>
-          <a:solidFill>
-            <a:srgbClr val="0545E8"/>
-          </a:solidFill>
-          <a:ln>
-            <a:noFill/>
-          </a:ln>
-          <a:effectLst/>
-        </p:spPr>
-        <p:style>
-          <a:lnRef idx="1">
-            <a:schemeClr val="accent1"/>
-          </a:lnRef>
-          <a:fillRef idx="3">
-            <a:schemeClr val="accent1"/>
-          </a:fillRef>
-          <a:effectRef idx="2">
-            <a:schemeClr val="accent1"/>
-          </a:effectRef>
-          <a:fontRef idx="minor">
-            <a:schemeClr val="lt1"/>
-          </a:fontRef>
-        </p:style>
-        <p:txBody>
-          <a:bodyPr rtlCol="0" anchor="ctr"/>
-          <a:lstStyle/>
-          <a:p>
-            <a:pPr algn="ctr"/>
-          </a:p>
-        </p:txBody>
-      </p:sp>
-      <p:sp>
-        <p:nvSpPr>
-          <p:cNvPr id="15" name="TextBox 14"/>
+          <p:cNvPr id="23" name="TextBox 22"/>
           <p:cNvSpPr txBox="1"/>
           <p:nvPr/>
         </p:nvSpPr>
         <p:spPr>
           <a:xfrm>
-            <a:off x="1030000" y="3970000"/>
-            <a:ext cx="2300000" cy="400000"/>
+            <a:off x="9466000" y="2030000"/>
+            <a:ext cx="2100000" cy="320000"/>
           </a:xfrm>
           <a:prstGeom prst="rect">
             <a:avLst/>
@@ -28091,7 +28776,7 @@
           </a:bodyPr>
           <a:lstStyle/>
           <a:p>
-            <a:pPr algn="l">
+            <a:pPr algn="ctr">
               <a:lnSpc>
                 <a:spcPct val="110000"/>
               </a:lnSpc>
@@ -28100,157 +28785,27 @@
               </a:spcAft>
             </a:pPr>
             <a:r>
-              <a:rPr sz="1400" b="1">
-                <a:solidFill>
-                  <a:srgbClr val="0545E8"/>
-                </a:solidFill>
-                <a:latin typeface="微软雅黑"/>
-              </a:rPr>
-              <a:t>学时学分</a:t>
-            </a:r>
-          </a:p>
-        </p:txBody>
-      </p:sp>
-      <p:sp>
-        <p:nvSpPr>
-          <p:cNvPr id="16" name="TextBox 15"/>
+              <a:rPr sz="1450" b="1">
+                <a:solidFill>
+                  <a:srgbClr val="FFFFFF"/>
+                </a:solidFill>
+                <a:latin typeface="微软雅黑"/>
+              </a:rPr>
+              <a:t>课程衔接</a:t>
+            </a:r>
+          </a:p>
+        </p:txBody>
+      </p:sp>
+      <p:sp>
+        <p:nvSpPr>
+          <p:cNvPr id="24" name="TextBox 23"/>
           <p:cNvSpPr txBox="1"/>
           <p:nvPr/>
         </p:nvSpPr>
         <p:spPr>
           <a:xfrm>
-            <a:off x="3500000" y="3820000"/>
-            <a:ext cx="9100000" cy="720000"/>
-          </a:xfrm>
-          <a:prstGeom prst="rect">
-            <a:avLst/>
-          </a:prstGeom>
-          <a:noFill/>
-        </p:spPr>
-        <p:txBody>
-          <a:bodyPr wrap="square" anchor="ctr">
-            <a:spAutoFit/>
-          </a:bodyPr>
-          <a:lstStyle/>
-          <a:p>
-            <a:pPr algn="l">
-              <a:lnSpc>
-                <a:spcPct val="115000"/>
-              </a:lnSpc>
-              <a:spcAft>
-                <a:spcPts val="600"/>
-              </a:spcAft>
-            </a:pPr>
-            <a:r>
-              <a:rPr sz="1200" b="0">
-                <a:solidFill>
-                  <a:srgbClr val="010328"/>
-                </a:solidFill>
-                <a:latin typeface="微软雅黑"/>
-              </a:rPr>
-              <a:t>48学时（理论24+实训24）· 3学分 · 第5-16周（12周×4课时，Python开课4周后即第5周开课）</a:t>
-            </a:r>
-          </a:p>
-        </p:txBody>
-      </p:sp>
-      <p:sp>
-        <p:nvSpPr>
-          <p:cNvPr id="17" name="Rectangle 16"/>
-          <p:cNvSpPr/>
-          <p:nvPr/>
-        </p:nvSpPr>
-        <p:spPr>
-          <a:xfrm>
-            <a:off x="760000" y="4720000"/>
-            <a:ext cx="10900000" cy="880000"/>
-          </a:xfrm>
-          <a:prstGeom prst="rect">
-            <a:avLst/>
-          </a:prstGeom>
-          <a:solidFill>
-            <a:srgbClr val="F3F6FD"/>
-          </a:solidFill>
-          <a:ln>
-            <a:noFill/>
-          </a:ln>
-          <a:effectLst/>
-        </p:spPr>
-        <p:style>
-          <a:lnRef idx="1">
-            <a:schemeClr val="accent1"/>
-          </a:lnRef>
-          <a:fillRef idx="3">
-            <a:schemeClr val="accent1"/>
-          </a:fillRef>
-          <a:effectRef idx="2">
-            <a:schemeClr val="accent1"/>
-          </a:effectRef>
-          <a:fontRef idx="minor">
-            <a:schemeClr val="lt1"/>
-          </a:fontRef>
-        </p:style>
-        <p:txBody>
-          <a:bodyPr rtlCol="0" anchor="ctr"/>
-          <a:lstStyle/>
-          <a:p>
-            <a:pPr algn="ctr"/>
-          </a:p>
-        </p:txBody>
-      </p:sp>
-      <p:sp>
-        <p:nvSpPr>
-          <p:cNvPr id="18" name="Rectangle 17"/>
-          <p:cNvSpPr/>
-          <p:nvPr/>
-        </p:nvSpPr>
-        <p:spPr>
-          <a:xfrm>
-            <a:off x="760000" y="4720000"/>
-            <a:ext cx="150000" cy="880000"/>
-          </a:xfrm>
-          <a:prstGeom prst="rect">
-            <a:avLst/>
-          </a:prstGeom>
-          <a:solidFill>
-            <a:srgbClr val="0545E8"/>
-          </a:solidFill>
-          <a:ln>
-            <a:noFill/>
-          </a:ln>
-          <a:effectLst/>
-        </p:spPr>
-        <p:style>
-          <a:lnRef idx="1">
-            <a:schemeClr val="accent1"/>
-          </a:lnRef>
-          <a:fillRef idx="3">
-            <a:schemeClr val="accent1"/>
-          </a:fillRef>
-          <a:effectRef idx="2">
-            <a:schemeClr val="accent1"/>
-          </a:effectRef>
-          <a:fontRef idx="minor">
-            <a:schemeClr val="lt1"/>
-          </a:fontRef>
-        </p:style>
-        <p:txBody>
-          <a:bodyPr rtlCol="0" anchor="ctr"/>
-          <a:lstStyle/>
-          <a:p>
-            <a:pPr algn="ctr"/>
-          </a:p>
-        </p:txBody>
-      </p:sp>
-      <p:sp>
-        <p:nvSpPr>
-          <p:cNvPr id="19" name="TextBox 18"/>
-          <p:cNvSpPr txBox="1"/>
-          <p:nvPr/>
-        </p:nvSpPr>
-        <p:spPr>
-          <a:xfrm>
-            <a:off x="1030000" y="4960000"/>
-            <a:ext cx="2300000" cy="400000"/>
+            <a:off x="9596000" y="2540000"/>
+            <a:ext cx="1840000" cy="3490000"/>
           </a:xfrm>
           <a:prstGeom prst="rect">
             <a:avLst/>
@@ -28265,228 +28820,14 @@
           <a:p>
             <a:pPr algn="l">
               <a:lnSpc>
-                <a:spcPct val="110000"/>
-              </a:lnSpc>
-              <a:spcAft>
-                <a:spcPts val="600"/>
-              </a:spcAft>
-            </a:pPr>
-            <a:r>
-              <a:rPr sz="1400" b="1">
-                <a:solidFill>
-                  <a:srgbClr val="0545E8"/>
-                </a:solidFill>
-                <a:latin typeface="微软雅黑"/>
-              </a:rPr>
-              <a:t>对接证书</a:t>
-            </a:r>
-          </a:p>
-        </p:txBody>
-      </p:sp>
-      <p:sp>
-        <p:nvSpPr>
-          <p:cNvPr id="20" name="TextBox 19"/>
-          <p:cNvSpPr txBox="1"/>
-          <p:nvPr/>
-        </p:nvSpPr>
-        <p:spPr>
-          <a:xfrm>
-            <a:off x="3500000" y="4810000"/>
-            <a:ext cx="9100000" cy="720000"/>
-          </a:xfrm>
-          <a:prstGeom prst="rect">
-            <a:avLst/>
-          </a:prstGeom>
-          <a:noFill/>
-        </p:spPr>
-        <p:txBody>
-          <a:bodyPr wrap="square" anchor="ctr">
-            <a:spAutoFit/>
-          </a:bodyPr>
-          <a:lstStyle/>
-          <a:p>
-            <a:pPr algn="l">
-              <a:lnSpc>
-                <a:spcPct val="115000"/>
-              </a:lnSpc>
-              <a:spcAft>
-                <a:spcPts val="600"/>
-              </a:spcAft>
-            </a:pPr>
-            <a:r>
-              <a:rPr sz="1200" b="0">
-                <a:solidFill>
-                  <a:srgbClr val="010328"/>
-                </a:solidFill>
-                <a:latin typeface="微软雅黑"/>
-              </a:rPr>
-              <a:t>1+X AI应用实践（初级=M1-M3/中级=M4/高级=M5）</a:t>
-            </a:r>
-          </a:p>
-        </p:txBody>
-      </p:sp>
-      <p:sp>
-        <p:nvSpPr>
-          <p:cNvPr id="21" name="Rectangle 20"/>
-          <p:cNvSpPr/>
-          <p:nvPr/>
-        </p:nvSpPr>
-        <p:spPr>
-          <a:xfrm>
-            <a:off x="760000" y="5710000"/>
-            <a:ext cx="10900000" cy="880000"/>
-          </a:xfrm>
-          <a:prstGeom prst="rect">
-            <a:avLst/>
-          </a:prstGeom>
-          <a:solidFill>
-            <a:srgbClr val="F3F6FD"/>
-          </a:solidFill>
-          <a:ln>
-            <a:noFill/>
-          </a:ln>
-          <a:effectLst/>
-        </p:spPr>
-        <p:style>
-          <a:lnRef idx="1">
-            <a:schemeClr val="accent1"/>
-          </a:lnRef>
-          <a:fillRef idx="3">
-            <a:schemeClr val="accent1"/>
-          </a:fillRef>
-          <a:effectRef idx="2">
-            <a:schemeClr val="accent1"/>
-          </a:effectRef>
-          <a:fontRef idx="minor">
-            <a:schemeClr val="lt1"/>
-          </a:fontRef>
-        </p:style>
-        <p:txBody>
-          <a:bodyPr rtlCol="0" anchor="ctr"/>
-          <a:lstStyle/>
-          <a:p>
-            <a:pPr algn="ctr"/>
-          </a:p>
-        </p:txBody>
-      </p:sp>
-      <p:sp>
-        <p:nvSpPr>
-          <p:cNvPr id="22" name="Rectangle 21"/>
-          <p:cNvSpPr/>
-          <p:nvPr/>
-        </p:nvSpPr>
-        <p:spPr>
-          <a:xfrm>
-            <a:off x="760000" y="5710000"/>
-            <a:ext cx="150000" cy="880000"/>
-          </a:xfrm>
-          <a:prstGeom prst="rect">
-            <a:avLst/>
-          </a:prstGeom>
-          <a:solidFill>
-            <a:srgbClr val="0545E8"/>
-          </a:solidFill>
-          <a:ln>
-            <a:noFill/>
-          </a:ln>
-          <a:effectLst/>
-        </p:spPr>
-        <p:style>
-          <a:lnRef idx="1">
-            <a:schemeClr val="accent1"/>
-          </a:lnRef>
-          <a:fillRef idx="3">
-            <a:schemeClr val="accent1"/>
-          </a:fillRef>
-          <a:effectRef idx="2">
-            <a:schemeClr val="accent1"/>
-          </a:effectRef>
-          <a:fontRef idx="minor">
-            <a:schemeClr val="lt1"/>
-          </a:fontRef>
-        </p:style>
-        <p:txBody>
-          <a:bodyPr rtlCol="0" anchor="ctr"/>
-          <a:lstStyle/>
-          <a:p>
-            <a:pPr algn="ctr"/>
-          </a:p>
-        </p:txBody>
-      </p:sp>
-      <p:sp>
-        <p:nvSpPr>
-          <p:cNvPr id="23" name="TextBox 22"/>
-          <p:cNvSpPr txBox="1"/>
-          <p:nvPr/>
-        </p:nvSpPr>
-        <p:spPr>
-          <a:xfrm>
-            <a:off x="1030000" y="5950000"/>
-            <a:ext cx="2300000" cy="400000"/>
-          </a:xfrm>
-          <a:prstGeom prst="rect">
-            <a:avLst/>
-          </a:prstGeom>
-          <a:noFill/>
-        </p:spPr>
-        <p:txBody>
-          <a:bodyPr wrap="square" anchor="t">
-            <a:spAutoFit/>
-          </a:bodyPr>
-          <a:lstStyle/>
-          <a:p>
-            <a:pPr algn="l">
-              <a:lnSpc>
-                <a:spcPct val="110000"/>
-              </a:lnSpc>
-              <a:spcAft>
-                <a:spcPts val="600"/>
-              </a:spcAft>
-            </a:pPr>
-            <a:r>
-              <a:rPr sz="1400" b="1">
-                <a:solidFill>
-                  <a:srgbClr val="0545E8"/>
-                </a:solidFill>
-                <a:latin typeface="微软雅黑"/>
-              </a:rPr>
-              <a:t>课程衔接</a:t>
-            </a:r>
-          </a:p>
-        </p:txBody>
-      </p:sp>
-      <p:sp>
-        <p:nvSpPr>
-          <p:cNvPr id="24" name="TextBox 23"/>
-          <p:cNvSpPr txBox="1"/>
-          <p:nvPr/>
-        </p:nvSpPr>
-        <p:spPr>
-          <a:xfrm>
-            <a:off x="3500000" y="5800000"/>
-            <a:ext cx="9100000" cy="720000"/>
-          </a:xfrm>
-          <a:prstGeom prst="rect">
-            <a:avLst/>
-          </a:prstGeom>
-          <a:noFill/>
-        </p:spPr>
-        <p:txBody>
-          <a:bodyPr wrap="square" anchor="ctr">
-            <a:spAutoFit/>
-          </a:bodyPr>
-          <a:lstStyle/>
-          <a:p>
-            <a:pPr algn="l">
-              <a:lnSpc>
-                <a:spcPct val="115000"/>
-              </a:lnSpc>
-              <a:spcAft>
-                <a:spcPts val="600"/>
-              </a:spcAft>
-            </a:pPr>
-            <a:r>
-              <a:rPr sz="1200" b="0">
+                <a:spcPct val="130000"/>
+              </a:lnSpc>
+              <a:spcAft>
+                <a:spcPts val="600"/>
+              </a:spcAft>
+            </a:pPr>
+            <a:r>
+              <a:rPr sz="1150" b="0">
                 <a:solidFill>
                   <a:srgbClr val="010328"/>
                 </a:solidFill>

</xml_diff>